<commit_message>
fix(pptx): Bilder proportional einpassen (Aspect-Ratio erhalten)
Co-Authored-By: Claude Opus 4.7 (1M context) <noreply@anthropic.com>
</commit_message>
<xml_diff>
--- a/presentation/SBB_Tracker_Praesentation.pptx
+++ b/presentation/SBB_Tracker_Praesentation.pptx
@@ -4900,7 +4900,7 @@
         <p:spPr>
           <a:xfrm>
             <a:off x="792327" y="1325880"/>
-            <a:ext cx="10607040" cy="4754880"/>
+            <a:ext cx="10607040" cy="4415756"/>
           </a:xfrm>
           <a:prstGeom prst="rect">
             <a:avLst/>
@@ -7500,7 +7500,7 @@
         <p:spPr>
           <a:xfrm>
             <a:off x="1229234" y="1325880"/>
-            <a:ext cx="9733227" cy="4754880"/>
+            <a:ext cx="9733226" cy="4754880"/>
           </a:xfrm>
           <a:prstGeom prst="rect">
             <a:avLst/>
@@ -7899,8 +7899,8 @@
         </p:blipFill>
         <p:spPr>
           <a:xfrm>
-            <a:off x="1849975" y="1325880"/>
-            <a:ext cx="8491744" cy="4754880"/>
+            <a:off x="1849976" y="1325880"/>
+            <a:ext cx="8491743" cy="4754880"/>
           </a:xfrm>
           <a:prstGeom prst="rect">
             <a:avLst/>

</xml_diff>

<commit_message>
feat(pptx): schoeneres Layout + lehrreiche Sprechernotizen je Slide
- Layout: Fusszeile mit Seitenzahl, Akzentlinie unter Titeln, Kernaussage-Boxen auf Ergebnis-Slides

- Notizen: pro Slide Sprechtext + einfache Erklaerung aller Fachbegriffe (p-Wert, Cohen's d, eta^2, OLS, R^2, Heteroskedastizitaet ...) + moegliche Pruefungsfragen

Co-Authored-By: Claude Opus 4.7 (1M context) <noreply@anthropic.com>
</commit_message>
<xml_diff>
--- a/presentation/SBB_Tracker_Praesentation.pptx
+++ b/presentation/SBB_Tracker_Praesentation.pptx
@@ -517,7 +517,19 @@
           <a:lstStyle/>
           <a:p>
             <a:r>
-              <a:t>Begrüssung: Wer wir sind. Wir analysieren die Pünktlichkeit der SBB auf Basis von 2.74 Mio echten Zug-Halten über 48 Betriebstage. Ziel: aus offenen Daten belastbare, ehrliche Aussagen ableiten.</a:t>
+              <a:t>SPRECHTEXT: «Grüezi, wir sind Joël und Patrick. Wir haben die Pünktlichkeit der SBB datengetrieben untersucht — auf Basis von 2.74 Millionen echten Zug-Halten über 48 Tage. Unser Ziel war, aus offenen Daten ehrliche, belastbare Aussagen abzuleiten.»</a:t>
+            </a:r>
+          </a:p>
+          <a:p/>
+          <a:p>
+            <a:r>
+              <a:t>ORGANISATION: Legt vorher fest, wer welche Slides spricht (z. B. Joël 1–8, Patrick 9–16) und nennt es kurz. In der Referentenansicht von PowerPoint seht ihr diese Notizen, das Publikum nicht.</a:t>
+            </a:r>
+          </a:p>
+          <a:p/>
+          <a:p>
+            <a:r>
+              <a:t>TON: ruhig, nicht auswendig runterleiern. Die Kernbotschaft des ganzen Projekts ist: Die Effekte sind statistisch klar, aber praktisch klein — und wir gehen ehrlich damit um.</a:t>
             </a:r>
           </a:p>
         </p:txBody>
@@ -587,7 +599,19 @@
           <a:lstStyle/>
           <a:p>
             <a:r>
-              <a:t>Die Heatmap zeigt, wann es kritisch wird: morgens und abends an Werktagen. Diese Erkenntnis fliesst direkt in die Webapp ein.</a:t>
+              <a:t>SPRECHTEXT: «Diese Heatmap zeigt, WANN es kritisch wird: dunkle Felder morgens und abends an Werktagen — die klassische Rush-Hour. Genau diese Erkenntnis bauen wir in der Webapp interaktiv nach.»</a:t>
+            </a:r>
+          </a:p>
+          <a:p/>
+          <a:p>
+            <a:r>
+              <a:t>GRAFIK ERKLÄREN: Zeilen = Wochentage (Mo–So), Spalten = Stunde 0–23, Farbe = durchschnittliche Verspätung. Je dunkler/röter, desto verspäteter. So sieht man Muster auf einen Blick statt in einer Zahlentabelle.</a:t>
+            </a:r>
+          </a:p>
+          <a:p/>
+          <a:p>
+            <a:r>
+              <a:t>Überleitung zur Demo: «Schauen wir uns das jetzt live in unserer Webapp an.»</a:t>
             </a:r>
           </a:p>
         </p:txBody>
@@ -657,7 +681,39 @@
           <a:lstStyle/>
           <a:p>
             <a:r>
-              <a:t>LIVE-DEMO ANSAGEN: Hier die interaktive Karte. Ich schiebe gleich den Hotspot-Regler hoch — dann bleiben nur die Verspätungs-Hotspots übrig, v.a. Grenzbahnhöfe wie Buchs SG und St. Margrethen. (In der Demo live zeigen.)</a:t>
+              <a:t>LIVE-DEMO (nicht nur die Folie zeigen, App wirklich bedienen!):</a:t>
+            </a:r>
+          </a:p>
+          <a:p>
+            <a:r>
+              <a:t>1. App vorher starten: 'streamlit run app/streamlit_app.py'.</a:t>
+            </a:r>
+          </a:p>
+          <a:p>
+            <a:r>
+              <a:t>2. «Jeder Punkt ist ein Bahnhof, die Farbe zeigt die mittlere Verspätung.»</a:t>
+            </a:r>
+          </a:p>
+          <a:p>
+            <a:r>
+              <a:t>3. Den rechten Regler 'Nur Hotspots' langsam hochziehen — die Karte dünnt aus, bis nur noch die rotesten Bahnhöfe übrig sind.</a:t>
+            </a:r>
+          </a:p>
+          <a:p>
+            <a:r>
+              <a:t>4. «Auffällig: die Hotspots liegen an den Grenzen — Buchs SG, St. Margrethen — weil internationale Züge ihre Verspätung importieren.»</a:t>
+            </a:r>
+          </a:p>
+          <a:p/>
+          <a:p>
+            <a:r>
+              <a:t>BEGRIFFE: 'Folium' = Python-Bibliothek für interaktive Landkarten. Der linke Regler blendet Bahnhöfe mit zu wenigen Daten aus (statistisch unsicher).</a:t>
+            </a:r>
+          </a:p>
+          <a:p/>
+          <a:p>
+            <a:r>
+              <a:t>Falls die Live-Demo hakt: dieser Screenshot dient als Fallback.</a:t>
             </a:r>
           </a:p>
         </p:txBody>
@@ -727,7 +783,49 @@
           <a:lstStyle/>
           <a:p>
             <a:r>
-              <a:t>Zweite Demo: der LLM-Pendler-Berater. Wichtig — er antwortet nur auf Basis unserer Statistik-Daten (kein Halluzinieren). Beispiel-Frage live stellen, z.B. 'Wann erwische ich am ehesten einen pünktlichen Zug?'</a:t>
+              <a:t>LIVE-DEMO:</a:t>
+            </a:r>
+          </a:p>
+          <a:p>
+            <a:r>
+              <a:t>1. Eine Beispielfrage anklicken oder tippen, z. B. 'Wann erwische ich am ehesten einen pünktlichen Zug?'.</a:t>
+            </a:r>
+          </a:p>
+          <a:p>
+            <a:r>
+              <a:t>2. «Das Sprachmodell bekommt unsere Statistik als Kontext mitgeliefert und darf NUR damit antworten — es soll nichts erfinden.»</a:t>
+            </a:r>
+          </a:p>
+          <a:p>
+            <a:r>
+              <a:t>3. Auf den Ausklapp-Bereich 'Welche Daten hat das Modell gesehen?' zeigen — das macht es transparent und überprüfbar.</a:t>
+            </a:r>
+          </a:p>
+          <a:p/>
+          <a:p>
+            <a:r>
+              <a:t>BEGRIFFE EINFACH:</a:t>
+            </a:r>
+          </a:p>
+          <a:p>
+            <a:r>
+              <a:t>• Sprachmodell / LLM = ein KI-Modell (hier Claude Sonnet 4.6), das Texte versteht und formuliert.</a:t>
+            </a:r>
+          </a:p>
+          <a:p>
+            <a:r>
+              <a:t>• 'Kontext mitgeben' = wir hängen die relevanten Zahlen an die Frage an, damit die Antwort auf unseren Daten basiert und nicht auf Allgemeinwissen.</a:t>
+            </a:r>
+          </a:p>
+          <a:p>
+            <a:r>
+              <a:t>• 'Halluzination' = wenn ein Modell plausibel klingende, aber falsche Dinge erfindet. Wir verhindern das durch klare Anweisung und mitgelieferte Fakten.</a:t>
+            </a:r>
+          </a:p>
+          <a:p/>
+          <a:p>
+            <a:r>
+              <a:t>MÖGLICHE FRAGE: 'Woher weiss man, dass es nicht doch erfindet?' — Wir geben die Datenbasis transparent aus und weisen das Modell explizit an, nur vorhandene Zahlen zu nennen.</a:t>
             </a:r>
           </a:p>
         </p:txBody>
@@ -797,7 +895,34 @@
           <a:lstStyle/>
           <a:p>
             <a:r>
-              <a:t>Der LLM liefert plausible Ursachen-Hypothesen für die schlimmsten Tage. Wir kommunizieren transparent, dass das Hypothesen sind, keine verifizierten Fakten — das ist methodisch sauber.</a:t>
+              <a:t>SPRECHTEXT: «Zusätzlich lassen wir das Sprachmodell die zehn schlimmsten Tage einordnen — also eine mögliche Ursache vorschlagen. Wir kommunizieren klar, dass das Hypothesen sind, keine bewiesenen Fakten.»</a:t>
+            </a:r>
+          </a:p>
+          <a:p/>
+          <a:p>
+            <a:r>
+              <a:t>BEGRIFFE EINFACH:</a:t>
+            </a:r>
+          </a:p>
+          <a:p>
+            <a:r>
+              <a:t>• 'Temperatur' beim Sprachmodell = Kreativitäts-Regler von 0 bis 1. Niedrig (0.2) = vorsichtig, faktentreu, wenig Fantasie. Genau das wollen wir hier.</a:t>
+            </a:r>
+          </a:p>
+          <a:p>
+            <a:r>
+              <a:t>• 'Feste Taxonomie' = wir geben eine vorgegebene Liste möglicher Ursachen vor, statt das Modell frei raten zu lassen.</a:t>
+            </a:r>
+          </a:p>
+          <a:p>
+            <a:r>
+              <a:t>• 'Konfidenz' = das Modell gibt selbst an, wie sicher es ist (hoch/mittel/niedrig). Achtung: das ist eine Selbsteinschätzung, nicht kalibriert.</a:t>
+            </a:r>
+          </a:p>
+          <a:p/>
+          <a:p>
+            <a:r>
+              <a:t>MÖGLICHE FRAGE: 'Ist das wissenschaftlich?' — Als qualitative Ergänzung ja, solange man es ehrlich als Hypothese kennzeichnet — was wir tun.</a:t>
             </a:r>
           </a:p>
         </p:txBody>
@@ -867,7 +992,34 @@
           <a:lstStyle/>
           <a:p>
             <a:r>
-              <a:t>Wir sind bei den Limitationen bewusst transparent — das ist ein Plus. Wichtigster Punkt: die Beobachtungen sind nicht unabhängig; wir adressieren das mit dem Robustheitstest und dem Effektstärken-Fokus.</a:t>
+              <a:t>SPRECHTEXT: «Zur Ehrlichkeit gehören die Grenzen. Der wichtigste Punkt: unsere Beobachtungen sind nicht unabhängig voneinander. Das macht rohe p-Werte zu optimistisch — deshalb der Tagesmittel-Gegencheck und der Fokus auf Effektstärken.»</a:t>
+            </a:r>
+          </a:p>
+          <a:p/>
+          <a:p>
+            <a:r>
+              <a:t>BEGRIFFE EINFACH:</a:t>
+            </a:r>
+          </a:p>
+          <a:p>
+            <a:r>
+              <a:t>• Pseudoreplikation = man tut so, als hätte man Millionen unabhängige Messungen, obwohl viele zusammenhängen (derselbe Zug an vielen Halten). Dann wirken Ergebnisse sicherer als sie sind.</a:t>
+            </a:r>
+          </a:p>
+          <a:p>
+            <a:r>
+              <a:t>• Saisonalität = jahreszeitliche Muster; wir haben nur Frühling, also keine Aussage über Winter.</a:t>
+            </a:r>
+          </a:p>
+          <a:p>
+            <a:r>
+              <a:t>• Korrelation ≠ Kausalität = zwei Dinge hängen zusammen, heisst nicht, dass eins das andere VERURSACHT (z. B. Sturm UND Bauarbeiten am selben Tag).</a:t>
+            </a:r>
+          </a:p>
+          <a:p/>
+          <a:p>
+            <a:r>
+              <a:t>Diese Slide ist ein PLUS, kein Schwächeeingeständnis: Wer Limitationen sauber benennt, zeigt methodisches Verständnis.</a:t>
             </a:r>
           </a:p>
         </p:txBody>
@@ -937,7 +1089,13 @@
           <a:lstStyle/>
           <a:p>
             <a:r>
-              <a:t>Take-aways: Die SBB ist sehr pünktlich; die messbaren Effekte sind klein; Verspätung ist grösstenteils Zufall/Einzelereignisse. Unser ehrlicher Umgang mit kleinen Effekten und Limitationen ist die methodische Stärke der Arbeit.</a:t>
+              <a:t>SPRECHTEXT: «Zusammengefasst: Die SBB ist sehr pünktlich. Die Effekte, die wir finden, sind echt, aber klein. Der grösste Teil der Verspätung ist Zufall im Einzelfall. Und die schlimmsten Bahnhöfe liegen an der Grenze. Unser Beitrag ist, diese Daten transparent und interaktiv zugänglich zu machen.»</a:t>
+            </a:r>
+          </a:p>
+          <a:p/>
+          <a:p>
+            <a:r>
+              <a:t>Das ist die Stelle, an der die rote Linie zusammenläuft: ehrlicher Umgang mit kleinen Effekten ist die methodische Stärke der Arbeit. Mit Selbstvertrauen sagen.</a:t>
             </a:r>
           </a:p>
         </p:txBody>
@@ -1007,7 +1165,13 @@
           <a:lstStyle/>
           <a:p>
             <a:r>
-              <a:t>Alles ist öffentlich und reproduzierbar. Abschluss + Überleitung zu Fragen.</a:t>
+              <a:t>SPRECHTEXT: «Alle Daten sind offen, der gesamte Code liegt öffentlich auf GitHub und ist mit den Build-Skripten reproduzierbar. Vielen Dank, wir freuen uns auf eure Fragen.»</a:t>
+            </a:r>
+          </a:p>
+          <a:p/>
+          <a:p>
+            <a:r>
+              <a:t>Ruhig abschliessen, Blickkontakt, kurze Pause für Fragen lassen. Wer welche Frage übernimmt, vorher grob klären.</a:t>
             </a:r>
           </a:p>
         </p:txBody>
@@ -1077,7 +1241,13 @@
           <a:lstStyle/>
           <a:p>
             <a:r>
-              <a:t>Kurzer Fahrplan. Schwerpunkt liegt auf den Ergebnissen und der Live-Demo der Webapp.</a:t>
+              <a:t>SPRECHTEXT: «Kurz der Fahrplan: erst das Warum und die Datenbasis, dann die Methodik, dann die Ergebnisse, eine Live-Demo, und am Schluss ehrlich die Grenzen.»</a:t>
+            </a:r>
+          </a:p>
+          <a:p/>
+          <a:p>
+            <a:r>
+              <a:t>Nicht vorlesen — nur in einem Satz überfliegen. Schwerpunkt ansagen: Ergebnisse und Demo.</a:t>
             </a:r>
           </a:p>
         </p:txBody>
@@ -1147,7 +1317,19 @@
           <a:lstStyle/>
           <a:p>
             <a:r>
-              <a:t>Die Schlagzeile '92.5% pünktlich' verdeckt grosse Unterschiede nach Tag, Linientyp und Ort. Unsere vier Forschungsfragen zerlegen das.</a:t>
+              <a:t>SPRECHTEXT: «Die SBB nennt eine Gesamt-Pünktlichkeit von 92.5 Prozent. Das ist ein Durchschnitt über alles und sagt mir wenig, wenn ich wissen will, wann und wo es konkret hakt. Deshalb diese vier Fragen.»</a:t>
+            </a:r>
+          </a:p>
+          <a:p/>
+          <a:p>
+            <a:r>
+              <a:t>HINTERGRUND, falls gefragt: 'Pünktlich' heisst bei der SBB &lt;3 Minuten Verspätung. Genau diese 3-Minuten-Schwelle benutzen wir auch.</a:t>
+            </a:r>
+          </a:p>
+          <a:p/>
+          <a:p>
+            <a:r>
+              <a:t>Die vier Fragen sind unser roter Faden — jede wird später mit einem eigenen Test beantwortet.</a:t>
             </a:r>
           </a:p>
         </p:txBody>
@@ -1217,7 +1399,34 @@
           <a:lstStyle/>
           <a:p>
             <a:r>
-              <a:t>Wir haben uns bewusst für Auflösung statt Zeitspanne entschieden: 48 Tage hochaufgelöst statt Jahre an Aggregaten. Die Volldaten 2019–2025 wären 1.1 TB. Wir haben ausserdem korrupte Zeitstempel sauber gefiltert.</a:t>
+              <a:t>SPRECHTEXT: «Basis sind 2.74 Millionen einzelne Zug-Halte über 48 Tage, aus drei offenen Quellen. Wir haben uns bewusst für Detailtiefe statt lange Zeitspanne entschieden: lieber 48 Tage ganz fein als Jahre an groben Summen — nur so kann man nach Stunde, Bahnhof und Wetter auswerten.»</a:t>
+            </a:r>
+          </a:p>
+          <a:p/>
+          <a:p>
+            <a:r>
+              <a:t>BEGRIFFE EINFACH:</a:t>
+            </a:r>
+          </a:p>
+          <a:p>
+            <a:r>
+              <a:t>• 'Halt' = ein einzelner Halt eines Zuges an einem Bahnhof. Ein Zug auf seiner Fahrt erzeugt viele Halte.</a:t>
+            </a:r>
+          </a:p>
+          <a:p>
+            <a:r>
+              <a:t>• 'Status REAL' = tatsächlich gemessene Ankunftszeit (keine Prognose).</a:t>
+            </a:r>
+          </a:p>
+          <a:p>
+            <a:r>
+              <a:t>• 'Betriebstag' = der Fahrplantag; ein Nachtzug um 00:30 zählt zum Vortag.</a:t>
+            </a:r>
+          </a:p>
+          <a:p/>
+          <a:p>
+            <a:r>
+              <a:t>MÖGLICHE FRAGE: 'Warum nur 48 Tage?' — Die kompletten Daten von 2019–2025 wären rund 1.1 Terabyte. 48 Tage in voller Auflösung sind aussagekräftiger für unsere Fragen als grobe Jahres-Aggregate.</a:t>
             </a:r>
           </a:p>
         </p:txBody>
@@ -1287,7 +1496,29 @@
           <a:lstStyle/>
           <a:p>
             <a:r>
-              <a:t>Wichtig: Wir berichten nicht nur p-Werte, sondern Effektstärken — bei 2.7 Mio Beobachtungen ist sonst alles 'signifikant'. Wir prüfen auch Robustheit und Regressions-Annahmen.</a:t>
+              <a:t>SPRECHTEXT: «Die Daten laufen durch eine Pipeline in eine SQLite-Datenbank und werden pro Halt um Zeit- und Wetter-Infos ergänzt. Darauf rechnen wir vier Tests. Wichtig: Wir berichten nie nur den p-Wert, sondern immer auch die Effektstärke.»</a:t>
+            </a:r>
+          </a:p>
+          <a:p/>
+          <a:p>
+            <a:r>
+              <a:t>DAS WICHTIGSTE KONZEPT (unbedingt verstehen):</a:t>
+            </a:r>
+          </a:p>
+          <a:p>
+            <a:r>
+              <a:t>• p-Wert = Wie wahrscheinlich wäre dieses Ergebnis, wenn es in Wirklichkeit KEINEN Unterschied gäbe? Klein (&lt; 0.05) heisst 'wahrscheinlich kein Zufall' = statistisch signifikant.</a:t>
+            </a:r>
+          </a:p>
+          <a:p>
+            <a:r>
+              <a:t>• ABER: Bei riesigen Datenmengen wird fast ALLES signifikant, auch winzige Unterschiede. Deshalb die Effektstärke: sie misst, wie GROSS der Unterschied praktisch ist. Genau das ist unsere Kernbotschaft.</a:t>
+            </a:r>
+          </a:p>
+          <a:p/>
+          <a:p>
+            <a:r>
+              <a:t>Die vier Tests sind nur Werkzeuge für je eine der vier Fragen — Details kommen auf den nächsten Slides.</a:t>
             </a:r>
           </a:p>
         </p:txBody>
@@ -1357,7 +1588,39 @@
           <a:lstStyle/>
           <a:p>
             <a:r>
-              <a:t>Werktage sind ~15s unpünktlicher — hochsignifikant, aber d=0.12 ist klein. Das ist unsere Kernbotschaft: statistische ≠ praktische Signifikanz. Der Tagesmittel-Test zeigt: der Effekt ist echt, kein Artefakt der Stichprobe.</a:t>
+              <a:t>SPRECHTEXT: «Werktage sind im Schnitt rund 15 Sekunden unpünktlicher als Wochenenden. Statistisch ist das glasklar. Aber 15 Sekunden merkt im Alltag niemand — die Effektstärke Cohen's d ist mit 0.12 klein. Genau dieser Unterschied zwischen 'signifikant' und 'relevant' zieht sich durch unsere ganze Arbeit.»</a:t>
+            </a:r>
+          </a:p>
+          <a:p/>
+          <a:p>
+            <a:r>
+              <a:t>BEGRIFFE EINFACH:</a:t>
+            </a:r>
+          </a:p>
+          <a:p>
+            <a:r>
+              <a:t>• Welch-t-Test = vergleicht zwei Mittelwerte und verträgt, dass die beiden Gruppen unterschiedlich stark streuen.</a:t>
+            </a:r>
+          </a:p>
+          <a:p>
+            <a:r>
+              <a:t>• Cohen's d = wie gross der Unterschied in 'Streuungs-Einheiten' ist. Faustregel: 0.2 klein, 0.5 mittel, 0.8 gross. Unser 0.12 ist also sehr klein.</a:t>
+            </a:r>
+          </a:p>
+          <a:p>
+            <a:r>
+              <a:t>• Konfidenzintervall = der Bereich, in dem der wahre Wert mit 95 % Sicherheit liegt. Hier sehr eng, weil wir so viele Daten haben.</a:t>
+            </a:r>
+          </a:p>
+          <a:p>
+            <a:r>
+              <a:t>• Mann-Whitney = ein Test, der keine Normalverteilung voraussetzt (arbeitet mit Rängen statt Werten) — als Gegenprobe.</a:t>
+            </a:r>
+          </a:p>
+          <a:p/>
+          <a:p>
+            <a:r>
+              <a:t>WARUM TAGESMITTEL? Unsere Millionen Halte sind nicht unabhängig (derselbe Zug, Bahnhof, Tag). Deshalb haben wir den Test auch nur auf den 48 Tagesdurchschnitten gerechnet — der Effekt bleibt. Das zeigt: er ist echt, kein Artefakt der grossen Zahl.</a:t>
             </a:r>
           </a:p>
         </p:txBody>
@@ -1427,7 +1690,39 @@
           <a:lstStyle/>
           <a:p>
             <a:r>
-              <a:t>Linientyp ist hochsignifikant, η²≈0.04 ist aber klein. Die Story: Internationale Züge (TGV, EC, RailJet) sammeln im Ausland Verspätung und bringen sie in die Schweiz. Innerschweizer IC/IR sind sehr pünktlich (~30s).</a:t>
+              <a:t>SPRECHTEXT: «Der Linientyp macht einen Unterschied — auch hier hochsignifikant, aber mit η² rund 0.04 wieder ein kleiner Effekt. Die eigentliche Geschichte: Internationale Züge wie TGV, EuroCity und RailJet sammeln im Ausland Verspätung und bringen sie in die Schweiz. Die inländischen IC und IR sind dagegen sehr pünktlich, um die 30 Sekunden.»</a:t>
+            </a:r>
+          </a:p>
+          <a:p/>
+          <a:p>
+            <a:r>
+              <a:t>BEGRIFFE EINFACH:</a:t>
+            </a:r>
+          </a:p>
+          <a:p>
+            <a:r>
+              <a:t>• ANOVA (Varianzanalyse) = vergleicht die Mittelwerte von MEHR als zwei Gruppen gleichzeitig (hier die Linientypen). Antwortet auf: 'Gibt es überhaupt irgendwo einen Unterschied?'</a:t>
+            </a:r>
+          </a:p>
+          <a:p>
+            <a:r>
+              <a:t>• F-Wert = die Test-Kennzahl der ANOVA; gross = die Gruppen unterscheiden sich deutlich relativ zur Streuung innerhalb der Gruppen.</a:t>
+            </a:r>
+          </a:p>
+          <a:p>
+            <a:r>
+              <a:t>• η² (eta-Quadrat) = Effektstärke der ANOVA: Anteil der Verspätungs-Schwankung, der durch den Linientyp erklärt wird. 0.04 = nur ~4 %.</a:t>
+            </a:r>
+          </a:p>
+          <a:p>
+            <a:r>
+              <a:t>• Tukey-HSD (im Notebook) = sagt zusätzlich, WELCHE Paare sich konkret unterscheiden, nicht nur dass es Unterschiede gibt.</a:t>
+            </a:r>
+          </a:p>
+          <a:p/>
+          <a:p>
+            <a:r>
+              <a:t>GRAFIK ERKLÄREN: Boxplot. Die Box ist der Bereich der mittleren 50 % der Werte, der Strich darin der Median. Je höher, desto verspäteter.</a:t>
             </a:r>
           </a:p>
         </p:txBody>
@@ -1497,7 +1792,34 @@
           <a:lstStyle/>
           <a:p>
             <a:r>
-              <a:t>Wetter wirkt in die erwartete Richtung (mehr Regen → mehr Verspätung), aber der Effekt ist praktisch vernachlässigbar. Wieder: Signifikanz wegen n, nicht wegen Relevanz. Wir zeigen das ehrlich.</a:t>
+              <a:t>SPRECHTEXT: «Wetter wirkt in die erwartete Richtung — mehr Regen, etwas mehr Verspätung. Aber der Zusammenhang ist extrem schwach. Wieder ein Lehrstück: Bei 2.7 Millionen Beobachtungen wird selbst ein winziger Zusammenhang hochsignifikant. Die Korrelation r liegt aber unter 0.04 — praktisch bedeutungslos.»</a:t>
+            </a:r>
+          </a:p>
+          <a:p/>
+          <a:p>
+            <a:r>
+              <a:t>BEGRIFFE EINFACH:</a:t>
+            </a:r>
+          </a:p>
+          <a:p>
+            <a:r>
+              <a:t>• Korrelation r = Mass für den Zusammenhang zweier Grössen, zwischen -1 und +1. 0 = kein Zusammenhang, ±1 = perfekter. Unsere Werte ~0.02–0.04 sind quasi null.</a:t>
+            </a:r>
+          </a:p>
+          <a:p>
+            <a:r>
+              <a:t>• Pearson = misst LINEAREN Zusammenhang. Spearman = misst, ob es generell rauf/runter geht (monoton), über Ränge. Dass beide ähnlich klein sind, bestätigt: da ist einfach wenig.</a:t>
+            </a:r>
+          </a:p>
+          <a:p>
+            <a:r>
+              <a:t>• 'erklärt &lt; 0.3 % der Varianz' = r² (das Quadrat von r) als Anteil.</a:t>
+            </a:r>
+          </a:p>
+          <a:p/>
+          <a:p>
+            <a:r>
+              <a:t>MÖGLICHE FRAGE: 'Warum überhaupt zeigen, wenn der Effekt null ist?' — Weil es methodisch ehrlich ist und genau den Unterschied signifikant/relevant demonstriert. Negative bzw. Null-Ergebnisse sauber zu berichten ist Teil guter Wissenschaft.</a:t>
             </a:r>
           </a:p>
         </p:txBody>
@@ -1567,7 +1889,44 @@
           <a:lstStyle/>
           <a:p>
             <a:r>
-              <a:t>Das gemeinsame Modell erklärt nur ~4.3% der Varianz. Das ist eine EHRLICHE Erkenntnis: Verspätungen sind dominant idiosynkratisch (Defekte, Einzelereignisse). Die Residuen zeigen Heteroskedastizität — wir benennen das offen. Vorzeichen/Grössen der Effekte sind plausibel.</a:t>
+              <a:t>SPRECHTEXT: «Zum Schluss kombinieren wir alle Faktoren in einem Modell. Es erklärt nur rund 4 Prozent der Verspätung. Das klingt wenig, ist aber eine ehrliche und wichtige Erkenntnis: Verspätung entsteht überwiegend aus einzelnen, zufälligen Ereignissen — Defekte, Störungen — und nicht aus Tag, Linientyp oder Wetter.»</a:t>
+            </a:r>
+          </a:p>
+          <a:p/>
+          <a:p>
+            <a:r>
+              <a:t>BEGRIFFE EINFACH:</a:t>
+            </a:r>
+          </a:p>
+          <a:p>
+            <a:r>
+              <a:t>• OLS-Regression = ein Modell, das die Verspätung gleichzeitig durch mehrere Einflussgrössen (Rush-Hour, Wochenende, Linientyp, Wetter) vorhersagt.</a:t>
+            </a:r>
+          </a:p>
+          <a:p>
+            <a:r>
+              <a:t>• Koeffizient = der Effekt eines Faktors in Sekunden. Beispiel: Rush-Hour +10 s heisst, zur Stosszeit kommen im Schnitt 10 s Verspätung dazu.</a:t>
+            </a:r>
+          </a:p>
+          <a:p>
+            <a:r>
+              <a:t>• R² = Anteil der Verspätungs-Schwankung, den das Modell erklärt. 0.043 = ~4 %. Der Rest ist nicht erklärt = idiosynkratisch (Einzelfälle).</a:t>
+            </a:r>
+          </a:p>
+          <a:p>
+            <a:r>
+              <a:t>• Heteroskedastizität (Breusch-Pagan-Test) = die Streuung der Fehler ist nicht konstant (bei grossen Verspätungen grösser). Wir benennen das offen.</a:t>
+            </a:r>
+          </a:p>
+          <a:p>
+            <a:r>
+              <a:t>• VIF = prüft, ob sich Einflussgrössen gegenseitig zu stark überlappen (Multikollinearität). Bei uns unauffällig.</a:t>
+            </a:r>
+          </a:p>
+          <a:p/>
+          <a:p>
+            <a:r>
+              <a:t>GRAFIK: Residuen-Plot. Jeder Punkt ist ein Halt; x = Vorhersage, y = Fehler. Die Trichterform nach rechts ist genau die Heteroskedastizität.</a:t>
             </a:r>
           </a:p>
         </p:txBody>
@@ -4633,7 +4992,7 @@
         </p:nvSpPr>
         <p:spPr>
           <a:xfrm>
-            <a:off x="731520" y="1828800"/>
+            <a:off x="731520" y="1737360"/>
             <a:ext cx="10698480" cy="1005840"/>
           </a:xfrm>
           <a:prstGeom prst="rect">
@@ -4672,7 +5031,7 @@
         </p:nvSpPr>
         <p:spPr>
           <a:xfrm>
-            <a:off x="731520" y="2971800"/>
+            <a:off x="731520" y="2926080"/>
             <a:ext cx="10698480" cy="1280160"/>
           </a:xfrm>
           <a:prstGeom prst="rect">
@@ -4809,7 +5168,7 @@
         <p:spPr>
           <a:xfrm>
             <a:off x="0" y="0"/>
-            <a:ext cx="12191695" cy="164592"/>
+            <a:ext cx="12191695" cy="146304"/>
           </a:xfrm>
           <a:prstGeom prst="rect">
             <a:avLst/>
@@ -4852,8 +5211,8 @@
         </p:nvSpPr>
         <p:spPr>
           <a:xfrm>
-            <a:off x="548640" y="320040"/>
-            <a:ext cx="11064240" cy="822960"/>
+            <a:off x="548640" y="384048"/>
+            <a:ext cx="11064240" cy="777240"/>
           </a:xfrm>
           <a:prstGeom prst="rect">
             <a:avLst/>
@@ -4872,7 +5231,7 @@
               </a:spcAft>
             </a:pPr>
             <a:r>
-              <a:rPr sz="3000" b="1">
+              <a:rPr sz="2800" b="1">
                 <a:solidFill>
                   <a:srgbClr val="EB0000"/>
                 </a:solidFill>
@@ -4880,12 +5239,56 @@
               </a:rPr>
               <a:t>Zeitliches Muster — Stunde × Wochentag</a:t>
             </a:r>
+          </a:p>
+        </p:txBody>
+      </p:sp>
+      <p:sp>
+        <p:nvSpPr>
+          <p:cNvPr id="4" name="Rectangle 3"/>
+          <p:cNvSpPr/>
+          <p:nvPr/>
+        </p:nvSpPr>
+        <p:spPr>
+          <a:xfrm>
+            <a:off x="566928" y="1170432"/>
+            <a:ext cx="2011680" cy="31750"/>
+          </a:xfrm>
+          <a:prstGeom prst="rect">
+            <a:avLst/>
+          </a:prstGeom>
+          <a:solidFill>
+            <a:srgbClr val="EB0000"/>
+          </a:solidFill>
+          <a:ln>
+            <a:noFill/>
+          </a:ln>
+          <a:effectLst/>
+        </p:spPr>
+        <p:style>
+          <a:lnRef idx="1">
+            <a:schemeClr val="accent1"/>
+          </a:lnRef>
+          <a:fillRef idx="3">
+            <a:schemeClr val="accent1"/>
+          </a:fillRef>
+          <a:effectRef idx="2">
+            <a:schemeClr val="accent1"/>
+          </a:effectRef>
+          <a:fontRef idx="minor">
+            <a:schemeClr val="lt1"/>
+          </a:fontRef>
+        </p:style>
+        <p:txBody>
+          <a:bodyPr rtlCol="0" anchor="ctr"/>
+          <a:lstStyle/>
+          <a:p>
+            <a:pPr algn="ctr"/>
           </a:p>
         </p:txBody>
       </p:sp>
       <p:pic>
         <p:nvPicPr>
-          <p:cNvPr id="4" name="Picture 3" descr="03_analyse_visualisierung_cell33_plot0.png"/>
+          <p:cNvPr id="5" name="Picture 4" descr="03_analyse_visualisierung_cell33_plot0.png"/>
           <p:cNvPicPr>
             <a:picLocks noChangeAspect="1"/>
           </p:cNvPicPr>
@@ -4899,7 +5302,7 @@
         </p:blipFill>
         <p:spPr>
           <a:xfrm>
-            <a:off x="792327" y="1325880"/>
+            <a:off x="792327" y="1371600"/>
             <a:ext cx="10607040" cy="4415756"/>
           </a:xfrm>
           <a:prstGeom prst="rect">
@@ -4909,14 +5312,14 @@
       </p:pic>
       <p:sp>
         <p:nvSpPr>
-          <p:cNvPr id="5" name="TextBox 4"/>
+          <p:cNvPr id="6" name="TextBox 5"/>
           <p:cNvSpPr txBox="1"/>
           <p:nvPr/>
         </p:nvSpPr>
         <p:spPr>
           <a:xfrm>
-            <a:off x="640080" y="6263640"/>
-            <a:ext cx="10881360" cy="457200"/>
+            <a:off x="640080" y="6126480"/>
+            <a:ext cx="10908792" cy="594360"/>
           </a:xfrm>
           <a:prstGeom prst="rect">
             <a:avLst/>
@@ -4941,7 +5344,85 @@
                 </a:solidFill>
                 <a:latin typeface="Segoe UI"/>
               </a:rPr>
-              <a:t>Mittlere Verspätung pro Wochentag und Stunde — Rush-Hour-Effekt sichtbar</a:t>
+              <a:t>Mittlere Verspätung je Wochentag und Stunde. Dunkler = mehr Verspätung.</a:t>
+            </a:r>
+          </a:p>
+        </p:txBody>
+      </p:sp>
+      <p:sp>
+        <p:nvSpPr>
+          <p:cNvPr id="7" name="TextBox 6"/>
+          <p:cNvSpPr txBox="1"/>
+          <p:nvPr/>
+        </p:nvSpPr>
+        <p:spPr>
+          <a:xfrm>
+            <a:off x="457200" y="6446520"/>
+            <a:ext cx="8229600" cy="320040"/>
+          </a:xfrm>
+          <a:prstGeom prst="rect">
+            <a:avLst/>
+          </a:prstGeom>
+          <a:noFill/>
+        </p:spPr>
+        <p:txBody>
+          <a:bodyPr wrap="square">
+            <a:spAutoFit/>
+          </a:bodyPr>
+          <a:lstStyle/>
+          <a:p>
+            <a:pPr algn="l">
+              <a:spcAft>
+                <a:spcPts val="800"/>
+              </a:spcAft>
+            </a:pPr>
+            <a:r>
+              <a:rPr sz="900" b="0">
+                <a:solidFill>
+                  <a:srgbClr val="999999"/>
+                </a:solidFill>
+                <a:latin typeface="Segoe UI"/>
+              </a:rPr>
+              <a:t>SBB Tracker · ZHAW Scientific Programming FS2026</a:t>
+            </a:r>
+          </a:p>
+        </p:txBody>
+      </p:sp>
+      <p:sp>
+        <p:nvSpPr>
+          <p:cNvPr id="8" name="TextBox 7"/>
+          <p:cNvSpPr txBox="1"/>
+          <p:nvPr/>
+        </p:nvSpPr>
+        <p:spPr>
+          <a:xfrm>
+            <a:off x="10972800" y="6446520"/>
+            <a:ext cx="822960" cy="320040"/>
+          </a:xfrm>
+          <a:prstGeom prst="rect">
+            <a:avLst/>
+          </a:prstGeom>
+          <a:noFill/>
+        </p:spPr>
+        <p:txBody>
+          <a:bodyPr wrap="square">
+            <a:spAutoFit/>
+          </a:bodyPr>
+          <a:lstStyle/>
+          <a:p>
+            <a:pPr algn="r">
+              <a:spcAft>
+                <a:spcPts val="800"/>
+              </a:spcAft>
+            </a:pPr>
+            <a:r>
+              <a:rPr sz="900" b="0">
+                <a:solidFill>
+                  <a:srgbClr val="999999"/>
+                </a:solidFill>
+                <a:latin typeface="Segoe UI"/>
+              </a:rPr>
+              <a:t>10</a:t>
             </a:r>
           </a:p>
         </p:txBody>
@@ -4981,7 +5462,7 @@
         <p:spPr>
           <a:xfrm>
             <a:off x="0" y="0"/>
-            <a:ext cx="12191695" cy="164592"/>
+            <a:ext cx="12191695" cy="146304"/>
           </a:xfrm>
           <a:prstGeom prst="rect">
             <a:avLst/>
@@ -5024,8 +5505,8 @@
         </p:nvSpPr>
         <p:spPr>
           <a:xfrm>
-            <a:off x="548640" y="320040"/>
-            <a:ext cx="11064240" cy="822960"/>
+            <a:off x="548640" y="384048"/>
+            <a:ext cx="11064240" cy="777240"/>
           </a:xfrm>
           <a:prstGeom prst="rect">
             <a:avLst/>
@@ -5044,7 +5525,7 @@
               </a:spcAft>
             </a:pPr>
             <a:r>
-              <a:rPr sz="3000" b="1">
+              <a:rPr sz="2800" b="1">
                 <a:solidFill>
                   <a:srgbClr val="EB0000"/>
                 </a:solidFill>
@@ -5052,12 +5533,56 @@
               </a:rPr>
               <a:t>Webapp — Verspätungs-Hotspots auf der Karte</a:t>
             </a:r>
+          </a:p>
+        </p:txBody>
+      </p:sp>
+      <p:sp>
+        <p:nvSpPr>
+          <p:cNvPr id="4" name="Rectangle 3"/>
+          <p:cNvSpPr/>
+          <p:nvPr/>
+        </p:nvSpPr>
+        <p:spPr>
+          <a:xfrm>
+            <a:off x="566928" y="1170432"/>
+            <a:ext cx="2011680" cy="31750"/>
+          </a:xfrm>
+          <a:prstGeom prst="rect">
+            <a:avLst/>
+          </a:prstGeom>
+          <a:solidFill>
+            <a:srgbClr val="EB0000"/>
+          </a:solidFill>
+          <a:ln>
+            <a:noFill/>
+          </a:ln>
+          <a:effectLst/>
+        </p:spPr>
+        <p:style>
+          <a:lnRef idx="1">
+            <a:schemeClr val="accent1"/>
+          </a:lnRef>
+          <a:fillRef idx="3">
+            <a:schemeClr val="accent1"/>
+          </a:fillRef>
+          <a:effectRef idx="2">
+            <a:schemeClr val="accent1"/>
+          </a:effectRef>
+          <a:fontRef idx="minor">
+            <a:schemeClr val="lt1"/>
+          </a:fontRef>
+        </p:style>
+        <p:txBody>
+          <a:bodyPr rtlCol="0" anchor="ctr"/>
+          <a:lstStyle/>
+          <a:p>
+            <a:pPr algn="ctr"/>
           </a:p>
         </p:txBody>
       </p:sp>
       <p:pic>
         <p:nvPicPr>
-          <p:cNvPr id="4" name="Picture 3" descr="webapp_01_karte.png"/>
+          <p:cNvPr id="5" name="Picture 4" descr="webapp_01_karte.png"/>
           <p:cNvPicPr>
             <a:picLocks noChangeAspect="1"/>
           </p:cNvPicPr>
@@ -5071,8 +5596,8 @@
         </p:blipFill>
         <p:spPr>
           <a:xfrm>
-            <a:off x="2291943" y="1325880"/>
-            <a:ext cx="7607808" cy="4754880"/>
+            <a:off x="2474823" y="1371600"/>
+            <a:ext cx="7242048" cy="4526280"/>
           </a:xfrm>
           <a:prstGeom prst="rect">
             <a:avLst/>
@@ -5081,14 +5606,14 @@
       </p:pic>
       <p:sp>
         <p:nvSpPr>
-          <p:cNvPr id="5" name="TextBox 4"/>
+          <p:cNvPr id="6" name="TextBox 5"/>
           <p:cNvSpPr txBox="1"/>
           <p:nvPr/>
         </p:nvSpPr>
         <p:spPr>
           <a:xfrm>
-            <a:off x="640080" y="6263640"/>
-            <a:ext cx="10881360" cy="457200"/>
+            <a:off x="640080" y="6126480"/>
+            <a:ext cx="10908792" cy="594360"/>
           </a:xfrm>
           <a:prstGeom prst="rect">
             <a:avLst/>
@@ -5113,7 +5638,85 @@
                 </a:solidFill>
                 <a:latin typeface="Segoe UI"/>
               </a:rPr>
-              <a:t>Folium-Karte · Farbe = Ø-Verspätung · Hotspot-Regler isoliert die Grenzbahnhöfe</a:t>
+              <a:t>Folium-Karte. Farbe = mittlere Verspätung. Mit dem Hotspot-Regler bleiben nur die kritischen Bahnhöfe übrig.</a:t>
+            </a:r>
+          </a:p>
+        </p:txBody>
+      </p:sp>
+      <p:sp>
+        <p:nvSpPr>
+          <p:cNvPr id="7" name="TextBox 6"/>
+          <p:cNvSpPr txBox="1"/>
+          <p:nvPr/>
+        </p:nvSpPr>
+        <p:spPr>
+          <a:xfrm>
+            <a:off x="457200" y="6446520"/>
+            <a:ext cx="8229600" cy="320040"/>
+          </a:xfrm>
+          <a:prstGeom prst="rect">
+            <a:avLst/>
+          </a:prstGeom>
+          <a:noFill/>
+        </p:spPr>
+        <p:txBody>
+          <a:bodyPr wrap="square">
+            <a:spAutoFit/>
+          </a:bodyPr>
+          <a:lstStyle/>
+          <a:p>
+            <a:pPr algn="l">
+              <a:spcAft>
+                <a:spcPts val="800"/>
+              </a:spcAft>
+            </a:pPr>
+            <a:r>
+              <a:rPr sz="900" b="0">
+                <a:solidFill>
+                  <a:srgbClr val="999999"/>
+                </a:solidFill>
+                <a:latin typeface="Segoe UI"/>
+              </a:rPr>
+              <a:t>SBB Tracker · ZHAW Scientific Programming FS2026</a:t>
+            </a:r>
+          </a:p>
+        </p:txBody>
+      </p:sp>
+      <p:sp>
+        <p:nvSpPr>
+          <p:cNvPr id="8" name="TextBox 7"/>
+          <p:cNvSpPr txBox="1"/>
+          <p:nvPr/>
+        </p:nvSpPr>
+        <p:spPr>
+          <a:xfrm>
+            <a:off x="10972800" y="6446520"/>
+            <a:ext cx="822960" cy="320040"/>
+          </a:xfrm>
+          <a:prstGeom prst="rect">
+            <a:avLst/>
+          </a:prstGeom>
+          <a:noFill/>
+        </p:spPr>
+        <p:txBody>
+          <a:bodyPr wrap="square">
+            <a:spAutoFit/>
+          </a:bodyPr>
+          <a:lstStyle/>
+          <a:p>
+            <a:pPr algn="r">
+              <a:spcAft>
+                <a:spcPts val="800"/>
+              </a:spcAft>
+            </a:pPr>
+            <a:r>
+              <a:rPr sz="900" b="0">
+                <a:solidFill>
+                  <a:srgbClr val="999999"/>
+                </a:solidFill>
+                <a:latin typeface="Segoe UI"/>
+              </a:rPr>
+              <a:t>11</a:t>
             </a:r>
           </a:p>
         </p:txBody>
@@ -5153,7 +5756,7 @@
         <p:spPr>
           <a:xfrm>
             <a:off x="0" y="0"/>
-            <a:ext cx="12191695" cy="164592"/>
+            <a:ext cx="12191695" cy="146304"/>
           </a:xfrm>
           <a:prstGeom prst="rect">
             <a:avLst/>
@@ -5196,8 +5799,8 @@
         </p:nvSpPr>
         <p:spPr>
           <a:xfrm>
-            <a:off x="548640" y="320040"/>
-            <a:ext cx="11064240" cy="822960"/>
+            <a:off x="548640" y="384048"/>
+            <a:ext cx="11064240" cy="777240"/>
           </a:xfrm>
           <a:prstGeom prst="rect">
             <a:avLst/>
@@ -5216,20 +5819,64 @@
               </a:spcAft>
             </a:pPr>
             <a:r>
-              <a:rPr sz="3000" b="1">
+              <a:rPr sz="2800" b="1">
                 <a:solidFill>
                   <a:srgbClr val="EB0000"/>
                 </a:solidFill>
                 <a:latin typeface="Segoe UI"/>
               </a:rPr>
-              <a:t>Webapp — Time-of-Day &amp; Pendler-Insight (LLM)</a:t>
-            </a:r>
+              <a:t>Webapp — Pendler-Insight (Sprachmodell)</a:t>
+            </a:r>
+          </a:p>
+        </p:txBody>
+      </p:sp>
+      <p:sp>
+        <p:nvSpPr>
+          <p:cNvPr id="4" name="Rectangle 3"/>
+          <p:cNvSpPr/>
+          <p:nvPr/>
+        </p:nvSpPr>
+        <p:spPr>
+          <a:xfrm>
+            <a:off x="566928" y="1170432"/>
+            <a:ext cx="2011680" cy="31750"/>
+          </a:xfrm>
+          <a:prstGeom prst="rect">
+            <a:avLst/>
+          </a:prstGeom>
+          <a:solidFill>
+            <a:srgbClr val="EB0000"/>
+          </a:solidFill>
+          <a:ln>
+            <a:noFill/>
+          </a:ln>
+          <a:effectLst/>
+        </p:spPr>
+        <p:style>
+          <a:lnRef idx="1">
+            <a:schemeClr val="accent1"/>
+          </a:lnRef>
+          <a:fillRef idx="3">
+            <a:schemeClr val="accent1"/>
+          </a:fillRef>
+          <a:effectRef idx="2">
+            <a:schemeClr val="accent1"/>
+          </a:effectRef>
+          <a:fontRef idx="minor">
+            <a:schemeClr val="lt1"/>
+          </a:fontRef>
+        </p:style>
+        <p:txBody>
+          <a:bodyPr rtlCol="0" anchor="ctr"/>
+          <a:lstStyle/>
+          <a:p>
+            <a:pPr algn="ctr"/>
           </a:p>
         </p:txBody>
       </p:sp>
       <p:pic>
         <p:nvPicPr>
-          <p:cNvPr id="4" name="Picture 3" descr="webapp_03_pendler_insight.png"/>
+          <p:cNvPr id="5" name="Picture 4" descr="webapp_03_pendler_insight.png"/>
           <p:cNvPicPr>
             <a:picLocks noChangeAspect="1"/>
           </p:cNvPicPr>
@@ -5243,8 +5890,8 @@
         </p:blipFill>
         <p:spPr>
           <a:xfrm>
-            <a:off x="2291943" y="1325880"/>
-            <a:ext cx="7607808" cy="4754880"/>
+            <a:off x="2474823" y="1371600"/>
+            <a:ext cx="7242048" cy="4526280"/>
           </a:xfrm>
           <a:prstGeom prst="rect">
             <a:avLst/>
@@ -5253,14 +5900,14 @@
       </p:pic>
       <p:sp>
         <p:nvSpPr>
-          <p:cNvPr id="5" name="TextBox 4"/>
+          <p:cNvPr id="6" name="TextBox 5"/>
           <p:cNvSpPr txBox="1"/>
           <p:nvPr/>
         </p:nvSpPr>
         <p:spPr>
           <a:xfrm>
-            <a:off x="640080" y="6263640"/>
-            <a:ext cx="10881360" cy="457200"/>
+            <a:off x="640080" y="6126480"/>
+            <a:ext cx="10908792" cy="594360"/>
           </a:xfrm>
           <a:prstGeom prst="rect">
             <a:avLst/>
@@ -5285,7 +5932,85 @@
                 </a:solidFill>
                 <a:latin typeface="Segoe UI"/>
               </a:rPr>
-              <a:t>LLM-Berater beantwortet Pendler-Fragen ausschliesslich aus den Projektdaten</a:t>
+              <a:t>Der Berater antwortet nur mit den Zahlen aus unseren Daten — er erfindet nichts dazu.</a:t>
+            </a:r>
+          </a:p>
+        </p:txBody>
+      </p:sp>
+      <p:sp>
+        <p:nvSpPr>
+          <p:cNvPr id="7" name="TextBox 6"/>
+          <p:cNvSpPr txBox="1"/>
+          <p:nvPr/>
+        </p:nvSpPr>
+        <p:spPr>
+          <a:xfrm>
+            <a:off x="457200" y="6446520"/>
+            <a:ext cx="8229600" cy="320040"/>
+          </a:xfrm>
+          <a:prstGeom prst="rect">
+            <a:avLst/>
+          </a:prstGeom>
+          <a:noFill/>
+        </p:spPr>
+        <p:txBody>
+          <a:bodyPr wrap="square">
+            <a:spAutoFit/>
+          </a:bodyPr>
+          <a:lstStyle/>
+          <a:p>
+            <a:pPr algn="l">
+              <a:spcAft>
+                <a:spcPts val="800"/>
+              </a:spcAft>
+            </a:pPr>
+            <a:r>
+              <a:rPr sz="900" b="0">
+                <a:solidFill>
+                  <a:srgbClr val="999999"/>
+                </a:solidFill>
+                <a:latin typeface="Segoe UI"/>
+              </a:rPr>
+              <a:t>SBB Tracker · ZHAW Scientific Programming FS2026</a:t>
+            </a:r>
+          </a:p>
+        </p:txBody>
+      </p:sp>
+      <p:sp>
+        <p:nvSpPr>
+          <p:cNvPr id="8" name="TextBox 7"/>
+          <p:cNvSpPr txBox="1"/>
+          <p:nvPr/>
+        </p:nvSpPr>
+        <p:spPr>
+          <a:xfrm>
+            <a:off x="10972800" y="6446520"/>
+            <a:ext cx="822960" cy="320040"/>
+          </a:xfrm>
+          <a:prstGeom prst="rect">
+            <a:avLst/>
+          </a:prstGeom>
+          <a:noFill/>
+        </p:spPr>
+        <p:txBody>
+          <a:bodyPr wrap="square">
+            <a:spAutoFit/>
+          </a:bodyPr>
+          <a:lstStyle/>
+          <a:p>
+            <a:pPr algn="r">
+              <a:spcAft>
+                <a:spcPts val="800"/>
+              </a:spcAft>
+            </a:pPr>
+            <a:r>
+              <a:rPr sz="900" b="0">
+                <a:solidFill>
+                  <a:srgbClr val="999999"/>
+                </a:solidFill>
+                <a:latin typeface="Segoe UI"/>
+              </a:rPr>
+              <a:t>12</a:t>
             </a:r>
           </a:p>
         </p:txBody>
@@ -5325,7 +6050,7 @@
         <p:spPr>
           <a:xfrm>
             <a:off x="0" y="0"/>
-            <a:ext cx="12191695" cy="164592"/>
+            <a:ext cx="12191695" cy="146304"/>
           </a:xfrm>
           <a:prstGeom prst="rect">
             <a:avLst/>
@@ -5368,8 +6093,8 @@
         </p:nvSpPr>
         <p:spPr>
           <a:xfrm>
-            <a:off x="548640" y="320040"/>
-            <a:ext cx="11064240" cy="822960"/>
+            <a:off x="548640" y="384048"/>
+            <a:ext cx="11064240" cy="777240"/>
           </a:xfrm>
           <a:prstGeom prst="rect">
             <a:avLst/>
@@ -5388,27 +6113,71 @@
               </a:spcAft>
             </a:pPr>
             <a:r>
-              <a:rPr sz="3000" b="1">
+              <a:rPr sz="2800" b="1">
                 <a:solidFill>
                   <a:srgbClr val="EB0000"/>
                 </a:solidFill>
                 <a:latin typeface="Segoe UI"/>
               </a:rPr>
-              <a:t>LLM-Analyse — Krisen-Tage</a:t>
-            </a:r>
-          </a:p>
-        </p:txBody>
-      </p:sp>
-      <p:sp>
-        <p:nvSpPr>
-          <p:cNvPr id="4" name="TextBox 3"/>
+              <a:t>Sprachmodell — Analyse der Krisen-Tage</a:t>
+            </a:r>
+          </a:p>
+        </p:txBody>
+      </p:sp>
+      <p:sp>
+        <p:nvSpPr>
+          <p:cNvPr id="4" name="Rectangle 3"/>
+          <p:cNvSpPr/>
+          <p:nvPr/>
+        </p:nvSpPr>
+        <p:spPr>
+          <a:xfrm>
+            <a:off x="566928" y="1170432"/>
+            <a:ext cx="2011680" cy="31750"/>
+          </a:xfrm>
+          <a:prstGeom prst="rect">
+            <a:avLst/>
+          </a:prstGeom>
+          <a:solidFill>
+            <a:srgbClr val="EB0000"/>
+          </a:solidFill>
+          <a:ln>
+            <a:noFill/>
+          </a:ln>
+          <a:effectLst/>
+        </p:spPr>
+        <p:style>
+          <a:lnRef idx="1">
+            <a:schemeClr val="accent1"/>
+          </a:lnRef>
+          <a:fillRef idx="3">
+            <a:schemeClr val="accent1"/>
+          </a:fillRef>
+          <a:effectRef idx="2">
+            <a:schemeClr val="accent1"/>
+          </a:effectRef>
+          <a:fontRef idx="minor">
+            <a:schemeClr val="lt1"/>
+          </a:fontRef>
+        </p:style>
+        <p:txBody>
+          <a:bodyPr rtlCol="0" anchor="ctr"/>
+          <a:lstStyle/>
+          <a:p>
+            <a:pPr algn="ctr"/>
+          </a:p>
+        </p:txBody>
+      </p:sp>
+      <p:sp>
+        <p:nvSpPr>
+          <p:cNvPr id="5" name="TextBox 4"/>
           <p:cNvSpPr txBox="1"/>
           <p:nvPr/>
         </p:nvSpPr>
         <p:spPr>
           <a:xfrm>
-            <a:off x="640080" y="1280160"/>
-            <a:ext cx="10881360" cy="5212079"/>
+            <a:off x="640080" y="1417320"/>
+            <a:ext cx="10881360" cy="5074920"/>
           </a:xfrm>
           <a:prstGeom prst="rect">
             <a:avLst/>
@@ -5433,7 +6202,7 @@
                 </a:solidFill>
                 <a:latin typeface="Segoe UI"/>
               </a:rPr>
-              <a:t>•  Claude Sonnet 4.6 klassifiziert die 10 verspätungsreichsten Tage</a:t>
+              <a:t>•  Claude klassifiziert die 10 verspätungsreichsten Tage nach Ursache</a:t>
             </a:r>
           </a:p>
           <a:p>
@@ -5449,7 +6218,7 @@
                 </a:solidFill>
                 <a:latin typeface="Segoe UI"/>
               </a:rPr>
-              <a:t>•  Feste Taxonomie (Wetter, Rush-Hour, Bahnhof-Ausfall, Bauarbeiten …)</a:t>
+              <a:t>•  Feste Auswahl an Kategorien (Wetter, Rush-Hour, Bahnhof-Ausfall, Bau …)</a:t>
             </a:r>
           </a:p>
           <a:p>
@@ -5465,7 +6234,7 @@
                 </a:solidFill>
                 <a:latin typeface="Segoe UI"/>
               </a:rPr>
-              <a:t>•  Temperatur 0.2 + Anweisung 'erfinde NICHTS' + Konfidenz-Skala</a:t>
+              <a:t>•  Niedrige 'Temperatur' (0.2) + Anweisung 'erfinde nichts' + Konfidenz-Angabe</a:t>
             </a:r>
           </a:p>
           <a:p>
@@ -5481,7 +6250,7 @@
                 </a:solidFill>
                 <a:latin typeface="Segoe UI"/>
               </a:rPr>
-              <a:t>•  Ehrlich: keine Ground-Truth-Validierung — qualitative Hypothesen,</a:t>
+              <a:t>•  Ehrlich: keine harte Verifikation — es sind qualitative Hypothesen</a:t>
             </a:r>
           </a:p>
           <a:p>
@@ -5497,7 +6266,85 @@
                 </a:solidFill>
                 <a:latin typeface="Segoe UI"/>
               </a:rPr>
-              <a:t>•  geplant: Abgleich mit Factiva-News als Validierung</a:t>
+              <a:t>–  geplant: Abgleich mit Schweizer News (Factiva) als Gegenprobe</a:t>
+            </a:r>
+          </a:p>
+        </p:txBody>
+      </p:sp>
+      <p:sp>
+        <p:nvSpPr>
+          <p:cNvPr id="6" name="TextBox 5"/>
+          <p:cNvSpPr txBox="1"/>
+          <p:nvPr/>
+        </p:nvSpPr>
+        <p:spPr>
+          <a:xfrm>
+            <a:off x="457200" y="6446520"/>
+            <a:ext cx="8229600" cy="320040"/>
+          </a:xfrm>
+          <a:prstGeom prst="rect">
+            <a:avLst/>
+          </a:prstGeom>
+          <a:noFill/>
+        </p:spPr>
+        <p:txBody>
+          <a:bodyPr wrap="square">
+            <a:spAutoFit/>
+          </a:bodyPr>
+          <a:lstStyle/>
+          <a:p>
+            <a:pPr algn="l">
+              <a:spcAft>
+                <a:spcPts val="800"/>
+              </a:spcAft>
+            </a:pPr>
+            <a:r>
+              <a:rPr sz="900" b="0">
+                <a:solidFill>
+                  <a:srgbClr val="999999"/>
+                </a:solidFill>
+                <a:latin typeface="Segoe UI"/>
+              </a:rPr>
+              <a:t>SBB Tracker · ZHAW Scientific Programming FS2026</a:t>
+            </a:r>
+          </a:p>
+        </p:txBody>
+      </p:sp>
+      <p:sp>
+        <p:nvSpPr>
+          <p:cNvPr id="7" name="TextBox 6"/>
+          <p:cNvSpPr txBox="1"/>
+          <p:nvPr/>
+        </p:nvSpPr>
+        <p:spPr>
+          <a:xfrm>
+            <a:off x="10972800" y="6446520"/>
+            <a:ext cx="822960" cy="320040"/>
+          </a:xfrm>
+          <a:prstGeom prst="rect">
+            <a:avLst/>
+          </a:prstGeom>
+          <a:noFill/>
+        </p:spPr>
+        <p:txBody>
+          <a:bodyPr wrap="square">
+            <a:spAutoFit/>
+          </a:bodyPr>
+          <a:lstStyle/>
+          <a:p>
+            <a:pPr algn="r">
+              <a:spcAft>
+                <a:spcPts val="800"/>
+              </a:spcAft>
+            </a:pPr>
+            <a:r>
+              <a:rPr sz="900" b="0">
+                <a:solidFill>
+                  <a:srgbClr val="999999"/>
+                </a:solidFill>
+                <a:latin typeface="Segoe UI"/>
+              </a:rPr>
+              <a:t>13</a:t>
             </a:r>
           </a:p>
         </p:txBody>
@@ -5537,7 +6384,7 @@
         <p:spPr>
           <a:xfrm>
             <a:off x="0" y="0"/>
-            <a:ext cx="12191695" cy="164592"/>
+            <a:ext cx="12191695" cy="146304"/>
           </a:xfrm>
           <a:prstGeom prst="rect">
             <a:avLst/>
@@ -5580,8 +6427,8 @@
         </p:nvSpPr>
         <p:spPr>
           <a:xfrm>
-            <a:off x="548640" y="320040"/>
-            <a:ext cx="11064240" cy="822960"/>
+            <a:off x="548640" y="384048"/>
+            <a:ext cx="11064240" cy="777240"/>
           </a:xfrm>
           <a:prstGeom prst="rect">
             <a:avLst/>
@@ -5600,7 +6447,7 @@
               </a:spcAft>
             </a:pPr>
             <a:r>
-              <a:rPr sz="3000" b="1">
+              <a:rPr sz="2800" b="1">
                 <a:solidFill>
                   <a:srgbClr val="EB0000"/>
                 </a:solidFill>
@@ -5613,14 +6460,58 @@
       </p:sp>
       <p:sp>
         <p:nvSpPr>
-          <p:cNvPr id="4" name="TextBox 3"/>
+          <p:cNvPr id="4" name="Rectangle 3"/>
+          <p:cNvSpPr/>
+          <p:nvPr/>
+        </p:nvSpPr>
+        <p:spPr>
+          <a:xfrm>
+            <a:off x="566928" y="1170432"/>
+            <a:ext cx="2011680" cy="31750"/>
+          </a:xfrm>
+          <a:prstGeom prst="rect">
+            <a:avLst/>
+          </a:prstGeom>
+          <a:solidFill>
+            <a:srgbClr val="EB0000"/>
+          </a:solidFill>
+          <a:ln>
+            <a:noFill/>
+          </a:ln>
+          <a:effectLst/>
+        </p:spPr>
+        <p:style>
+          <a:lnRef idx="1">
+            <a:schemeClr val="accent1"/>
+          </a:lnRef>
+          <a:fillRef idx="3">
+            <a:schemeClr val="accent1"/>
+          </a:fillRef>
+          <a:effectRef idx="2">
+            <a:schemeClr val="accent1"/>
+          </a:effectRef>
+          <a:fontRef idx="minor">
+            <a:schemeClr val="lt1"/>
+          </a:fontRef>
+        </p:style>
+        <p:txBody>
+          <a:bodyPr rtlCol="0" anchor="ctr"/>
+          <a:lstStyle/>
+          <a:p>
+            <a:pPr algn="ctr"/>
+          </a:p>
+        </p:txBody>
+      </p:sp>
+      <p:sp>
+        <p:nvSpPr>
+          <p:cNvPr id="5" name="TextBox 4"/>
           <p:cNvSpPr txBox="1"/>
           <p:nvPr/>
         </p:nvSpPr>
         <p:spPr>
           <a:xfrm>
-            <a:off x="640080" y="1280160"/>
-            <a:ext cx="10881360" cy="5212079"/>
+            <a:off x="640080" y="1417320"/>
+            <a:ext cx="10881360" cy="5074920"/>
           </a:xfrm>
           <a:prstGeom prst="rect">
             <a:avLst/>
@@ -5645,7 +6536,7 @@
                 </a:solidFill>
                 <a:latin typeface="Segoe UI"/>
               </a:rPr>
-              <a:t>•  Nicht-Unabhängigkeit: Halte sind geschachtelt (Pseudoreplikation) →</a:t>
+              <a:t>•  Beobachtungen nicht unabhängig (gleicher Zug/Bahnhof/Tag) — Pseudoreplikation</a:t>
             </a:r>
           </a:p>
           <a:p>
@@ -5661,7 +6552,7 @@
                 </a:solidFill>
                 <a:latin typeface="Segoe UI"/>
               </a:rPr>
-              <a:t>•  begegnet mit Tagesmittel-Robustheit + Fokus auf Effektstärken</a:t>
+              <a:t>–  dagegen: Tagesmittel-Gegencheck + Fokus auf Effektstärken</a:t>
             </a:r>
           </a:p>
           <a:p>
@@ -5677,7 +6568,7 @@
                 </a:solidFill>
                 <a:latin typeface="Segoe UI"/>
               </a:rPr>
-              <a:t>•  Zeitraum 48 Tage (Frühjahr) — keine Saisonalität</a:t>
+              <a:t>•  Nur 48 Tage im Frühling — keine Saisonalität (Winter, Bausaison fehlen)</a:t>
             </a:r>
           </a:p>
           <a:p>
@@ -5693,7 +6584,7 @@
                 </a:solidFill>
                 <a:latin typeface="Segoe UI"/>
               </a:rPr>
-              <a:t>•  Nur SBB; Wetter-Distanz bis ~40 km (Mikroklima verloren)</a:t>
+              <a:t>•  Nur SBB; Wetter-Station bis ~40 km entfernt (Mikroklima geht verloren)</a:t>
             </a:r>
           </a:p>
           <a:p>
@@ -5709,9 +6600,32 @@
                 </a:solidFill>
                 <a:latin typeface="Segoe UI"/>
               </a:rPr>
-              <a:t>•  Heteroskedastizität in OLS; Bonferroni α=0.0125 (alle Tests bestehen)</a:t>
-            </a:r>
-          </a:p>
+              <a:t>•  Korrelation ist nicht Kausalität (mögliche versteckte Faktoren)</a:t>
+            </a:r>
+          </a:p>
+        </p:txBody>
+      </p:sp>
+      <p:sp>
+        <p:nvSpPr>
+          <p:cNvPr id="6" name="TextBox 5"/>
+          <p:cNvSpPr txBox="1"/>
+          <p:nvPr/>
+        </p:nvSpPr>
+        <p:spPr>
+          <a:xfrm>
+            <a:off x="457200" y="6446520"/>
+            <a:ext cx="8229600" cy="320040"/>
+          </a:xfrm>
+          <a:prstGeom prst="rect">
+            <a:avLst/>
+          </a:prstGeom>
+          <a:noFill/>
+        </p:spPr>
+        <p:txBody>
+          <a:bodyPr wrap="square">
+            <a:spAutoFit/>
+          </a:bodyPr>
+          <a:lstStyle/>
           <a:p>
             <a:pPr algn="l">
               <a:spcAft>
@@ -5719,13 +6633,52 @@
               </a:spcAft>
             </a:pPr>
             <a:r>
-              <a:rPr sz="1800" b="0">
-                <a:solidFill>
-                  <a:srgbClr val="1A1A1A"/>
-                </a:solidFill>
-                <a:latin typeface="Segoe UI"/>
-              </a:rPr>
-              <a:t>•  Korrelation ≠ Kausalität (Confounder, z.B. Sturm + Bauarbeiten)</a:t>
+              <a:rPr sz="900" b="0">
+                <a:solidFill>
+                  <a:srgbClr val="999999"/>
+                </a:solidFill>
+                <a:latin typeface="Segoe UI"/>
+              </a:rPr>
+              <a:t>SBB Tracker · ZHAW Scientific Programming FS2026</a:t>
+            </a:r>
+          </a:p>
+        </p:txBody>
+      </p:sp>
+      <p:sp>
+        <p:nvSpPr>
+          <p:cNvPr id="7" name="TextBox 6"/>
+          <p:cNvSpPr txBox="1"/>
+          <p:nvPr/>
+        </p:nvSpPr>
+        <p:spPr>
+          <a:xfrm>
+            <a:off x="10972800" y="6446520"/>
+            <a:ext cx="822960" cy="320040"/>
+          </a:xfrm>
+          <a:prstGeom prst="rect">
+            <a:avLst/>
+          </a:prstGeom>
+          <a:noFill/>
+        </p:spPr>
+        <p:txBody>
+          <a:bodyPr wrap="square">
+            <a:spAutoFit/>
+          </a:bodyPr>
+          <a:lstStyle/>
+          <a:p>
+            <a:pPr algn="r">
+              <a:spcAft>
+                <a:spcPts val="800"/>
+              </a:spcAft>
+            </a:pPr>
+            <a:r>
+              <a:rPr sz="900" b="0">
+                <a:solidFill>
+                  <a:srgbClr val="999999"/>
+                </a:solidFill>
+                <a:latin typeface="Segoe UI"/>
+              </a:rPr>
+              <a:t>14</a:t>
             </a:r>
           </a:p>
         </p:txBody>
@@ -5765,7 +6718,7 @@
         <p:spPr>
           <a:xfrm>
             <a:off x="0" y="0"/>
-            <a:ext cx="12191695" cy="164592"/>
+            <a:ext cx="12191695" cy="146304"/>
           </a:xfrm>
           <a:prstGeom prst="rect">
             <a:avLst/>
@@ -5808,8 +6761,8 @@
         </p:nvSpPr>
         <p:spPr>
           <a:xfrm>
-            <a:off x="548640" y="320040"/>
-            <a:ext cx="11064240" cy="822960"/>
+            <a:off x="548640" y="384048"/>
+            <a:ext cx="11064240" cy="777240"/>
           </a:xfrm>
           <a:prstGeom prst="rect">
             <a:avLst/>
@@ -5828,7 +6781,7 @@
               </a:spcAft>
             </a:pPr>
             <a:r>
-              <a:rPr sz="3000" b="1">
+              <a:rPr sz="2800" b="1">
                 <a:solidFill>
                   <a:srgbClr val="EB0000"/>
                 </a:solidFill>
@@ -5841,14 +6794,58 @@
       </p:sp>
       <p:sp>
         <p:nvSpPr>
-          <p:cNvPr id="4" name="TextBox 3"/>
+          <p:cNvPr id="4" name="Rectangle 3"/>
+          <p:cNvSpPr/>
+          <p:nvPr/>
+        </p:nvSpPr>
+        <p:spPr>
+          <a:xfrm>
+            <a:off x="566928" y="1170432"/>
+            <a:ext cx="2011680" cy="31750"/>
+          </a:xfrm>
+          <a:prstGeom prst="rect">
+            <a:avLst/>
+          </a:prstGeom>
+          <a:solidFill>
+            <a:srgbClr val="EB0000"/>
+          </a:solidFill>
+          <a:ln>
+            <a:noFill/>
+          </a:ln>
+          <a:effectLst/>
+        </p:spPr>
+        <p:style>
+          <a:lnRef idx="1">
+            <a:schemeClr val="accent1"/>
+          </a:lnRef>
+          <a:fillRef idx="3">
+            <a:schemeClr val="accent1"/>
+          </a:fillRef>
+          <a:effectRef idx="2">
+            <a:schemeClr val="accent1"/>
+          </a:effectRef>
+          <a:fontRef idx="minor">
+            <a:schemeClr val="lt1"/>
+          </a:fontRef>
+        </p:style>
+        <p:txBody>
+          <a:bodyPr rtlCol="0" anchor="ctr"/>
+          <a:lstStyle/>
+          <a:p>
+            <a:pPr algn="ctr"/>
+          </a:p>
+        </p:txBody>
+      </p:sp>
+      <p:sp>
+        <p:nvSpPr>
+          <p:cNvPr id="5" name="TextBox 4"/>
           <p:cNvSpPr txBox="1"/>
           <p:nvPr/>
         </p:nvSpPr>
         <p:spPr>
           <a:xfrm>
-            <a:off x="640080" y="1280160"/>
-            <a:ext cx="10881360" cy="5212079"/>
+            <a:off x="640080" y="1417320"/>
+            <a:ext cx="10881360" cy="5074920"/>
           </a:xfrm>
           <a:prstGeom prst="rect">
             <a:avLst/>
@@ -5873,7 +6870,7 @@
                 </a:solidFill>
                 <a:latin typeface="Segoe UI"/>
               </a:rPr>
-              <a:t>•  SBB-Pünktlichkeit ist hoch (~95 % unter 3 Min) und räumlich robust</a:t>
+              <a:t>•  Die SBB ist sehr pünktlich (~95 % unter 3 Minuten) und räumlich stabil</a:t>
             </a:r>
           </a:p>
           <a:p>
@@ -5889,7 +6886,7 @@
                 </a:solidFill>
                 <a:latin typeface="Segoe UI"/>
               </a:rPr>
-              <a:t>•  Werktag-, Linientyp- und Wetter-Effekte sind real, aber praktisch klein</a:t>
+              <a:t>•  Tag, Linientyp und Wetter wirken messbar, aber praktisch klein</a:t>
             </a:r>
           </a:p>
           <a:p>
@@ -5905,7 +6902,7 @@
                 </a:solidFill>
                 <a:latin typeface="Segoe UI"/>
               </a:rPr>
-              <a:t>•  Verspätung ist dominant idiosynkratisch (R² nur ~4 %) — ehrlich beziffert</a:t>
+              <a:t>•  Verspätung ist überwiegend idiosynkratisch (Modell erklärt nur ~4 %)</a:t>
             </a:r>
           </a:p>
           <a:p>
@@ -5921,7 +6918,7 @@
                 </a:solidFill>
                 <a:latin typeface="Segoe UI"/>
               </a:rPr>
-              <a:t>•  Hotspots sind Grenzbahnhöfe (Import-Effekt internationaler Züge)</a:t>
+              <a:t>•  Die grössten Hotspots sind Grenzbahnhöfe (Import-Effekt aus dem Ausland)</a:t>
             </a:r>
           </a:p>
           <a:p>
@@ -5937,7 +6934,85 @@
                 </a:solidFill>
                 <a:latin typeface="Segoe UI"/>
               </a:rPr>
-              <a:t>•  Mehrwert: interaktive Webapp + LLM machen die Daten zugänglich</a:t>
+              <a:t>•  Mehrwert: Webapp und Sprachmodell machen die Daten zugänglich</a:t>
+            </a:r>
+          </a:p>
+        </p:txBody>
+      </p:sp>
+      <p:sp>
+        <p:nvSpPr>
+          <p:cNvPr id="6" name="TextBox 5"/>
+          <p:cNvSpPr txBox="1"/>
+          <p:nvPr/>
+        </p:nvSpPr>
+        <p:spPr>
+          <a:xfrm>
+            <a:off x="457200" y="6446520"/>
+            <a:ext cx="8229600" cy="320040"/>
+          </a:xfrm>
+          <a:prstGeom prst="rect">
+            <a:avLst/>
+          </a:prstGeom>
+          <a:noFill/>
+        </p:spPr>
+        <p:txBody>
+          <a:bodyPr wrap="square">
+            <a:spAutoFit/>
+          </a:bodyPr>
+          <a:lstStyle/>
+          <a:p>
+            <a:pPr algn="l">
+              <a:spcAft>
+                <a:spcPts val="800"/>
+              </a:spcAft>
+            </a:pPr>
+            <a:r>
+              <a:rPr sz="900" b="0">
+                <a:solidFill>
+                  <a:srgbClr val="999999"/>
+                </a:solidFill>
+                <a:latin typeface="Segoe UI"/>
+              </a:rPr>
+              <a:t>SBB Tracker · ZHAW Scientific Programming FS2026</a:t>
+            </a:r>
+          </a:p>
+        </p:txBody>
+      </p:sp>
+      <p:sp>
+        <p:nvSpPr>
+          <p:cNvPr id="7" name="TextBox 6"/>
+          <p:cNvSpPr txBox="1"/>
+          <p:nvPr/>
+        </p:nvSpPr>
+        <p:spPr>
+          <a:xfrm>
+            <a:off x="10972800" y="6446520"/>
+            <a:ext cx="822960" cy="320040"/>
+          </a:xfrm>
+          <a:prstGeom prst="rect">
+            <a:avLst/>
+          </a:prstGeom>
+          <a:noFill/>
+        </p:spPr>
+        <p:txBody>
+          <a:bodyPr wrap="square">
+            <a:spAutoFit/>
+          </a:bodyPr>
+          <a:lstStyle/>
+          <a:p>
+            <a:pPr algn="r">
+              <a:spcAft>
+                <a:spcPts val="800"/>
+              </a:spcAft>
+            </a:pPr>
+            <a:r>
+              <a:rPr sz="900" b="0">
+                <a:solidFill>
+                  <a:srgbClr val="999999"/>
+                </a:solidFill>
+                <a:latin typeface="Segoe UI"/>
+              </a:rPr>
+              <a:t>15</a:t>
             </a:r>
           </a:p>
         </p:txBody>
@@ -5977,7 +7052,7 @@
         <p:spPr>
           <a:xfrm>
             <a:off x="0" y="0"/>
-            <a:ext cx="12191695" cy="164592"/>
+            <a:ext cx="12191695" cy="146304"/>
           </a:xfrm>
           <a:prstGeom prst="rect">
             <a:avLst/>
@@ -6020,8 +7095,8 @@
         </p:nvSpPr>
         <p:spPr>
           <a:xfrm>
-            <a:off x="548640" y="320040"/>
-            <a:ext cx="11064240" cy="822960"/>
+            <a:off x="548640" y="384048"/>
+            <a:ext cx="11064240" cy="777240"/>
           </a:xfrm>
           <a:prstGeom prst="rect">
             <a:avLst/>
@@ -6040,27 +7115,71 @@
               </a:spcAft>
             </a:pPr>
             <a:r>
-              <a:rPr sz="3000" b="1">
+              <a:rPr sz="2800" b="1">
                 <a:solidFill>
                   <a:srgbClr val="EB0000"/>
                 </a:solidFill>
                 <a:latin typeface="Segoe UI"/>
               </a:rPr>
-              <a:t>Quellen, Code &amp; Reproduzierbarkeit</a:t>
-            </a:r>
-          </a:p>
-        </p:txBody>
-      </p:sp>
-      <p:sp>
-        <p:nvSpPr>
-          <p:cNvPr id="4" name="TextBox 3"/>
+              <a:t>Quellen, Code und Reproduzierbarkeit</a:t>
+            </a:r>
+          </a:p>
+        </p:txBody>
+      </p:sp>
+      <p:sp>
+        <p:nvSpPr>
+          <p:cNvPr id="4" name="Rectangle 3"/>
+          <p:cNvSpPr/>
+          <p:nvPr/>
+        </p:nvSpPr>
+        <p:spPr>
+          <a:xfrm>
+            <a:off x="566928" y="1170432"/>
+            <a:ext cx="2011680" cy="31750"/>
+          </a:xfrm>
+          <a:prstGeom prst="rect">
+            <a:avLst/>
+          </a:prstGeom>
+          <a:solidFill>
+            <a:srgbClr val="EB0000"/>
+          </a:solidFill>
+          <a:ln>
+            <a:noFill/>
+          </a:ln>
+          <a:effectLst/>
+        </p:spPr>
+        <p:style>
+          <a:lnRef idx="1">
+            <a:schemeClr val="accent1"/>
+          </a:lnRef>
+          <a:fillRef idx="3">
+            <a:schemeClr val="accent1"/>
+          </a:fillRef>
+          <a:effectRef idx="2">
+            <a:schemeClr val="accent1"/>
+          </a:effectRef>
+          <a:fontRef idx="minor">
+            <a:schemeClr val="lt1"/>
+          </a:fontRef>
+        </p:style>
+        <p:txBody>
+          <a:bodyPr rtlCol="0" anchor="ctr"/>
+          <a:lstStyle/>
+          <a:p>
+            <a:pPr algn="ctr"/>
+          </a:p>
+        </p:txBody>
+      </p:sp>
+      <p:sp>
+        <p:nvSpPr>
+          <p:cNvPr id="5" name="TextBox 4"/>
           <p:cNvSpPr txBox="1"/>
           <p:nvPr/>
         </p:nvSpPr>
         <p:spPr>
           <a:xfrm>
-            <a:off x="640080" y="1280160"/>
-            <a:ext cx="10881360" cy="5212079"/>
+            <a:off x="640080" y="1417320"/>
+            <a:ext cx="10881360" cy="5074920"/>
           </a:xfrm>
           <a:prstGeom prst="rect">
             <a:avLst/>
@@ -6085,7 +7204,7 @@
                 </a:solidFill>
                 <a:latin typeface="Segoe UI"/>
               </a:rPr>
-              <a:t>•  Daten: opentransportdata.swiss · data.sbb.ch · MeteoSchweiz (CC-BY)</a:t>
+              <a:t>•  Daten: opentransportdata.swiss · data.sbb.ch · MeteoSchweiz (alle CC-BY)</a:t>
             </a:r>
           </a:p>
           <a:p>
@@ -6101,7 +7220,7 @@
                 </a:solidFill>
                 <a:latin typeface="Segoe UI"/>
               </a:rPr>
-              <a:t>•  Code (MIT): github.com/Mrgincinamon/SBB-Tracking</a:t>
+              <a:t>•  Code (MIT-Lizenz): github.com/Mrgincinamon/SBB-Tracking</a:t>
             </a:r>
           </a:p>
           <a:p>
@@ -6117,7 +7236,7 @@
                 </a:solidFill>
                 <a:latin typeface="Segoe UI"/>
               </a:rPr>
-              <a:t>•  Reproduzierbar: requirements.txt + venv + Build-Skripte für Notebooks</a:t>
+              <a:t>•  Vollständig reproduzierbar: requirements.txt + Build-Skripte</a:t>
             </a:r>
           </a:p>
           <a:p>
@@ -6149,7 +7268,85 @@
                 </a:solidFill>
                 <a:latin typeface="Segoe UI"/>
               </a:rPr>
-              <a:t>•  Danke — Fragen?</a:t>
+              <a:t>•  Vielen Dank — gerne Fragen!</a:t>
+            </a:r>
+          </a:p>
+        </p:txBody>
+      </p:sp>
+      <p:sp>
+        <p:nvSpPr>
+          <p:cNvPr id="6" name="TextBox 5"/>
+          <p:cNvSpPr txBox="1"/>
+          <p:nvPr/>
+        </p:nvSpPr>
+        <p:spPr>
+          <a:xfrm>
+            <a:off x="457200" y="6446520"/>
+            <a:ext cx="8229600" cy="320040"/>
+          </a:xfrm>
+          <a:prstGeom prst="rect">
+            <a:avLst/>
+          </a:prstGeom>
+          <a:noFill/>
+        </p:spPr>
+        <p:txBody>
+          <a:bodyPr wrap="square">
+            <a:spAutoFit/>
+          </a:bodyPr>
+          <a:lstStyle/>
+          <a:p>
+            <a:pPr algn="l">
+              <a:spcAft>
+                <a:spcPts val="800"/>
+              </a:spcAft>
+            </a:pPr>
+            <a:r>
+              <a:rPr sz="900" b="0">
+                <a:solidFill>
+                  <a:srgbClr val="999999"/>
+                </a:solidFill>
+                <a:latin typeface="Segoe UI"/>
+              </a:rPr>
+              <a:t>SBB Tracker · ZHAW Scientific Programming FS2026</a:t>
+            </a:r>
+          </a:p>
+        </p:txBody>
+      </p:sp>
+      <p:sp>
+        <p:nvSpPr>
+          <p:cNvPr id="7" name="TextBox 6"/>
+          <p:cNvSpPr txBox="1"/>
+          <p:nvPr/>
+        </p:nvSpPr>
+        <p:spPr>
+          <a:xfrm>
+            <a:off x="10972800" y="6446520"/>
+            <a:ext cx="822960" cy="320040"/>
+          </a:xfrm>
+          <a:prstGeom prst="rect">
+            <a:avLst/>
+          </a:prstGeom>
+          <a:noFill/>
+        </p:spPr>
+        <p:txBody>
+          <a:bodyPr wrap="square">
+            <a:spAutoFit/>
+          </a:bodyPr>
+          <a:lstStyle/>
+          <a:p>
+            <a:pPr algn="r">
+              <a:spcAft>
+                <a:spcPts val="800"/>
+              </a:spcAft>
+            </a:pPr>
+            <a:r>
+              <a:rPr sz="900" b="0">
+                <a:solidFill>
+                  <a:srgbClr val="999999"/>
+                </a:solidFill>
+                <a:latin typeface="Segoe UI"/>
+              </a:rPr>
+              <a:t>16</a:t>
             </a:r>
           </a:p>
         </p:txBody>
@@ -6189,7 +7386,7 @@
         <p:spPr>
           <a:xfrm>
             <a:off x="0" y="0"/>
-            <a:ext cx="12191695" cy="164592"/>
+            <a:ext cx="12191695" cy="146304"/>
           </a:xfrm>
           <a:prstGeom prst="rect">
             <a:avLst/>
@@ -6232,8 +7429,8 @@
         </p:nvSpPr>
         <p:spPr>
           <a:xfrm>
-            <a:off x="548640" y="320040"/>
-            <a:ext cx="11064240" cy="822960"/>
+            <a:off x="548640" y="384048"/>
+            <a:ext cx="11064240" cy="777240"/>
           </a:xfrm>
           <a:prstGeom prst="rect">
             <a:avLst/>
@@ -6252,7 +7449,7 @@
               </a:spcAft>
             </a:pPr>
             <a:r>
-              <a:rPr sz="3000" b="1">
+              <a:rPr sz="2800" b="1">
                 <a:solidFill>
                   <a:srgbClr val="EB0000"/>
                 </a:solidFill>
@@ -6265,14 +7462,58 @@
       </p:sp>
       <p:sp>
         <p:nvSpPr>
-          <p:cNvPr id="4" name="TextBox 3"/>
+          <p:cNvPr id="4" name="Rectangle 3"/>
+          <p:cNvSpPr/>
+          <p:nvPr/>
+        </p:nvSpPr>
+        <p:spPr>
+          <a:xfrm>
+            <a:off x="566928" y="1170432"/>
+            <a:ext cx="2011680" cy="31750"/>
+          </a:xfrm>
+          <a:prstGeom prst="rect">
+            <a:avLst/>
+          </a:prstGeom>
+          <a:solidFill>
+            <a:srgbClr val="EB0000"/>
+          </a:solidFill>
+          <a:ln>
+            <a:noFill/>
+          </a:ln>
+          <a:effectLst/>
+        </p:spPr>
+        <p:style>
+          <a:lnRef idx="1">
+            <a:schemeClr val="accent1"/>
+          </a:lnRef>
+          <a:fillRef idx="3">
+            <a:schemeClr val="accent1"/>
+          </a:fillRef>
+          <a:effectRef idx="2">
+            <a:schemeClr val="accent1"/>
+          </a:effectRef>
+          <a:fontRef idx="minor">
+            <a:schemeClr val="lt1"/>
+          </a:fontRef>
+        </p:style>
+        <p:txBody>
+          <a:bodyPr rtlCol="0" anchor="ctr"/>
+          <a:lstStyle/>
+          <a:p>
+            <a:pPr algn="ctr"/>
+          </a:p>
+        </p:txBody>
+      </p:sp>
+      <p:sp>
+        <p:nvSpPr>
+          <p:cNvPr id="5" name="TextBox 4"/>
           <p:cNvSpPr txBox="1"/>
           <p:nvPr/>
         </p:nvSpPr>
         <p:spPr>
           <a:xfrm>
-            <a:off x="640080" y="1280160"/>
-            <a:ext cx="10881360" cy="5212079"/>
+            <a:off x="640080" y="1417320"/>
+            <a:ext cx="10881360" cy="5074920"/>
           </a:xfrm>
           <a:prstGeom prst="rect">
             <a:avLst/>
@@ -6297,7 +7538,7 @@
                 </a:solidFill>
                 <a:latin typeface="Segoe UI"/>
               </a:rPr>
-              <a:t>•  Motivation &amp; Forschungsfragen</a:t>
+              <a:t>•  Motivation und Forschungsfragen</a:t>
             </a:r>
           </a:p>
           <a:p>
@@ -6313,7 +7554,7 @@
                 </a:solidFill>
                 <a:latin typeface="Segoe UI"/>
               </a:rPr>
-              <a:t>•  Datengrundlage &amp; Design-Entscheidung</a:t>
+              <a:t>•  Datengrundlage und eine zentrale Design-Entscheidung</a:t>
             </a:r>
           </a:p>
           <a:p>
@@ -6329,7 +7570,7 @@
                 </a:solidFill>
                 <a:latin typeface="Segoe UI"/>
               </a:rPr>
-              <a:t>•  Methodik: 4 statistische Tests + LLM</a:t>
+              <a:t>•  Methodik: vier statistische Tests plus ein Sprachmodell</a:t>
             </a:r>
           </a:p>
           <a:p>
@@ -6345,7 +7586,7 @@
                 </a:solidFill>
                 <a:latin typeface="Segoe UI"/>
               </a:rPr>
-              <a:t>•  Ergebnisse (mit Effektstärken)</a:t>
+              <a:t>•  Ergebnisse — mit Fokus auf Effektstärken</a:t>
             </a:r>
           </a:p>
           <a:p>
@@ -6361,7 +7602,7 @@
                 </a:solidFill>
                 <a:latin typeface="Segoe UI"/>
               </a:rPr>
-              <a:t>•  Interaktive Webapp (Live-Demo)</a:t>
+              <a:t>•  Live-Demo der Webapp</a:t>
             </a:r>
           </a:p>
           <a:p>
@@ -6377,7 +7618,85 @@
                 </a:solidFill>
                 <a:latin typeface="Segoe UI"/>
               </a:rPr>
-              <a:t>•  Limitationen &amp; Schlussfolgerungen</a:t>
+              <a:t>•  Limitationen und Schlussfolgerungen</a:t>
+            </a:r>
+          </a:p>
+        </p:txBody>
+      </p:sp>
+      <p:sp>
+        <p:nvSpPr>
+          <p:cNvPr id="6" name="TextBox 5"/>
+          <p:cNvSpPr txBox="1"/>
+          <p:nvPr/>
+        </p:nvSpPr>
+        <p:spPr>
+          <a:xfrm>
+            <a:off x="457200" y="6446520"/>
+            <a:ext cx="8229600" cy="320040"/>
+          </a:xfrm>
+          <a:prstGeom prst="rect">
+            <a:avLst/>
+          </a:prstGeom>
+          <a:noFill/>
+        </p:spPr>
+        <p:txBody>
+          <a:bodyPr wrap="square">
+            <a:spAutoFit/>
+          </a:bodyPr>
+          <a:lstStyle/>
+          <a:p>
+            <a:pPr algn="l">
+              <a:spcAft>
+                <a:spcPts val="800"/>
+              </a:spcAft>
+            </a:pPr>
+            <a:r>
+              <a:rPr sz="900" b="0">
+                <a:solidFill>
+                  <a:srgbClr val="999999"/>
+                </a:solidFill>
+                <a:latin typeface="Segoe UI"/>
+              </a:rPr>
+              <a:t>SBB Tracker · ZHAW Scientific Programming FS2026</a:t>
+            </a:r>
+          </a:p>
+        </p:txBody>
+      </p:sp>
+      <p:sp>
+        <p:nvSpPr>
+          <p:cNvPr id="7" name="TextBox 6"/>
+          <p:cNvSpPr txBox="1"/>
+          <p:nvPr/>
+        </p:nvSpPr>
+        <p:spPr>
+          <a:xfrm>
+            <a:off x="10972800" y="6446520"/>
+            <a:ext cx="822960" cy="320040"/>
+          </a:xfrm>
+          <a:prstGeom prst="rect">
+            <a:avLst/>
+          </a:prstGeom>
+          <a:noFill/>
+        </p:spPr>
+        <p:txBody>
+          <a:bodyPr wrap="square">
+            <a:spAutoFit/>
+          </a:bodyPr>
+          <a:lstStyle/>
+          <a:p>
+            <a:pPr algn="r">
+              <a:spcAft>
+                <a:spcPts val="800"/>
+              </a:spcAft>
+            </a:pPr>
+            <a:r>
+              <a:rPr sz="900" b="0">
+                <a:solidFill>
+                  <a:srgbClr val="999999"/>
+                </a:solidFill>
+                <a:latin typeface="Segoe UI"/>
+              </a:rPr>
+              <a:t>2</a:t>
             </a:r>
           </a:p>
         </p:txBody>
@@ -6417,7 +7736,7 @@
         <p:spPr>
           <a:xfrm>
             <a:off x="0" y="0"/>
-            <a:ext cx="12191695" cy="164592"/>
+            <a:ext cx="12191695" cy="146304"/>
           </a:xfrm>
           <a:prstGeom prst="rect">
             <a:avLst/>
@@ -6460,8 +7779,8 @@
         </p:nvSpPr>
         <p:spPr>
           <a:xfrm>
-            <a:off x="548640" y="320040"/>
-            <a:ext cx="11064240" cy="822960"/>
+            <a:off x="548640" y="384048"/>
+            <a:ext cx="11064240" cy="777240"/>
           </a:xfrm>
           <a:prstGeom prst="rect">
             <a:avLst/>
@@ -6480,27 +7799,71 @@
               </a:spcAft>
             </a:pPr>
             <a:r>
-              <a:rPr sz="3000" b="1">
+              <a:rPr sz="2800" b="1">
                 <a:solidFill>
                   <a:srgbClr val="EB0000"/>
                 </a:solidFill>
                 <a:latin typeface="Segoe UI"/>
               </a:rPr>
-              <a:t>Motivation &amp; Forschungsfragen</a:t>
-            </a:r>
-          </a:p>
-        </p:txBody>
-      </p:sp>
-      <p:sp>
-        <p:nvSpPr>
-          <p:cNvPr id="4" name="TextBox 3"/>
+              <a:t>Motivation und Forschungsfragen</a:t>
+            </a:r>
+          </a:p>
+        </p:txBody>
+      </p:sp>
+      <p:sp>
+        <p:nvSpPr>
+          <p:cNvPr id="4" name="Rectangle 3"/>
+          <p:cNvSpPr/>
+          <p:nvPr/>
+        </p:nvSpPr>
+        <p:spPr>
+          <a:xfrm>
+            <a:off x="566928" y="1170432"/>
+            <a:ext cx="2011680" cy="31750"/>
+          </a:xfrm>
+          <a:prstGeom prst="rect">
+            <a:avLst/>
+          </a:prstGeom>
+          <a:solidFill>
+            <a:srgbClr val="EB0000"/>
+          </a:solidFill>
+          <a:ln>
+            <a:noFill/>
+          </a:ln>
+          <a:effectLst/>
+        </p:spPr>
+        <p:style>
+          <a:lnRef idx="1">
+            <a:schemeClr val="accent1"/>
+          </a:lnRef>
+          <a:fillRef idx="3">
+            <a:schemeClr val="accent1"/>
+          </a:fillRef>
+          <a:effectRef idx="2">
+            <a:schemeClr val="accent1"/>
+          </a:effectRef>
+          <a:fontRef idx="minor">
+            <a:schemeClr val="lt1"/>
+          </a:fontRef>
+        </p:style>
+        <p:txBody>
+          <a:bodyPr rtlCol="0" anchor="ctr"/>
+          <a:lstStyle/>
+          <a:p>
+            <a:pPr algn="ctr"/>
+          </a:p>
+        </p:txBody>
+      </p:sp>
+      <p:sp>
+        <p:nvSpPr>
+          <p:cNvPr id="5" name="TextBox 4"/>
           <p:cNvSpPr txBox="1"/>
           <p:nvPr/>
         </p:nvSpPr>
         <p:spPr>
           <a:xfrm>
-            <a:off x="640080" y="1280160"/>
-            <a:ext cx="10881360" cy="5212079"/>
+            <a:off x="640080" y="1417320"/>
+            <a:ext cx="10881360" cy="5074920"/>
           </a:xfrm>
           <a:prstGeom prst="rect">
             <a:avLst/>
@@ -6525,7 +7888,7 @@
                 </a:solidFill>
                 <a:latin typeface="Segoe UI"/>
               </a:rPr>
-              <a:t>•  Die offizielle SBB-Pünktlichkeit (92.5 %) ist ein Aggregat — für die</a:t>
+              <a:t>•  Die offizielle SBB-Pünktlichkeit (92.5 %) ist ein Durchschnitt —</a:t>
             </a:r>
           </a:p>
           <a:p>
@@ -6541,7 +7904,7 @@
                 </a:solidFill>
                 <a:latin typeface="Segoe UI"/>
               </a:rPr>
-              <a:t>•  individuelle Reiseplanung wenig hilfreich. Wir gehen ins Detail:</a:t>
+              <a:t>•  für die konkrete Reiseplanung wenig hilfreich. Wir gehen ins Detail:</a:t>
             </a:r>
           </a:p>
           <a:p>
@@ -6557,7 +7920,7 @@
                 </a:solidFill>
                 <a:latin typeface="Segoe UI"/>
               </a:rPr>
-              <a:t>•  F1: Sind Werktage unpünktlicher als Wochenenden?</a:t>
+              <a:t>–  F1: Sind Werktage unpünktlicher als Wochenenden?</a:t>
             </a:r>
           </a:p>
           <a:p>
@@ -6573,7 +7936,7 @@
                 </a:solidFill>
                 <a:latin typeface="Segoe UI"/>
               </a:rPr>
-              <a:t>•  F2: Beeinflusst der Linientyp (S, IC, IR …) die Verspätung?</a:t>
+              <a:t>–  F2: Beeinflusst der Linientyp (S-Bahn, IC, IR …) die Verspätung?</a:t>
             </a:r>
           </a:p>
           <a:p>
@@ -6589,7 +7952,7 @@
                 </a:solidFill>
                 <a:latin typeface="Segoe UI"/>
               </a:rPr>
-              <a:t>•  F3: Korreliert Wetter (Regen, Temperatur) mit Verspätung?</a:t>
+              <a:t>–  F3: Hängt das Wetter (Regen, Temperatur) mit Verspätung zusammen?</a:t>
             </a:r>
           </a:p>
           <a:p>
@@ -6605,7 +7968,85 @@
                 </a:solidFill>
                 <a:latin typeface="Segoe UI"/>
               </a:rPr>
-              <a:t>•  F4: Welche Faktoren erklären Verspätung gemeinsam (Regression)?</a:t>
+              <a:t>–  F4: Welche Faktoren erklären Verspätung gemeinsam (Regression)?</a:t>
+            </a:r>
+          </a:p>
+        </p:txBody>
+      </p:sp>
+      <p:sp>
+        <p:nvSpPr>
+          <p:cNvPr id="6" name="TextBox 5"/>
+          <p:cNvSpPr txBox="1"/>
+          <p:nvPr/>
+        </p:nvSpPr>
+        <p:spPr>
+          <a:xfrm>
+            <a:off x="457200" y="6446520"/>
+            <a:ext cx="8229600" cy="320040"/>
+          </a:xfrm>
+          <a:prstGeom prst="rect">
+            <a:avLst/>
+          </a:prstGeom>
+          <a:noFill/>
+        </p:spPr>
+        <p:txBody>
+          <a:bodyPr wrap="square">
+            <a:spAutoFit/>
+          </a:bodyPr>
+          <a:lstStyle/>
+          <a:p>
+            <a:pPr algn="l">
+              <a:spcAft>
+                <a:spcPts val="800"/>
+              </a:spcAft>
+            </a:pPr>
+            <a:r>
+              <a:rPr sz="900" b="0">
+                <a:solidFill>
+                  <a:srgbClr val="999999"/>
+                </a:solidFill>
+                <a:latin typeface="Segoe UI"/>
+              </a:rPr>
+              <a:t>SBB Tracker · ZHAW Scientific Programming FS2026</a:t>
+            </a:r>
+          </a:p>
+        </p:txBody>
+      </p:sp>
+      <p:sp>
+        <p:nvSpPr>
+          <p:cNvPr id="7" name="TextBox 6"/>
+          <p:cNvSpPr txBox="1"/>
+          <p:nvPr/>
+        </p:nvSpPr>
+        <p:spPr>
+          <a:xfrm>
+            <a:off x="10972800" y="6446520"/>
+            <a:ext cx="822960" cy="320040"/>
+          </a:xfrm>
+          <a:prstGeom prst="rect">
+            <a:avLst/>
+          </a:prstGeom>
+          <a:noFill/>
+        </p:spPr>
+        <p:txBody>
+          <a:bodyPr wrap="square">
+            <a:spAutoFit/>
+          </a:bodyPr>
+          <a:lstStyle/>
+          <a:p>
+            <a:pPr algn="r">
+              <a:spcAft>
+                <a:spcPts val="800"/>
+              </a:spcAft>
+            </a:pPr>
+            <a:r>
+              <a:rPr sz="900" b="0">
+                <a:solidFill>
+                  <a:srgbClr val="999999"/>
+                </a:solidFill>
+                <a:latin typeface="Segoe UI"/>
+              </a:rPr>
+              <a:t>3</a:t>
             </a:r>
           </a:p>
         </p:txBody>
@@ -6645,7 +8086,7 @@
         <p:spPr>
           <a:xfrm>
             <a:off x="0" y="0"/>
-            <a:ext cx="12191695" cy="164592"/>
+            <a:ext cx="12191695" cy="146304"/>
           </a:xfrm>
           <a:prstGeom prst="rect">
             <a:avLst/>
@@ -6688,8 +8129,8 @@
         </p:nvSpPr>
         <p:spPr>
           <a:xfrm>
-            <a:off x="548640" y="320040"/>
-            <a:ext cx="11064240" cy="822960"/>
+            <a:off x="548640" y="384048"/>
+            <a:ext cx="11064240" cy="777240"/>
           </a:xfrm>
           <a:prstGeom prst="rect">
             <a:avLst/>
@@ -6708,7 +8149,7 @@
               </a:spcAft>
             </a:pPr>
             <a:r>
-              <a:rPr sz="3000" b="1">
+              <a:rPr sz="2800" b="1">
                 <a:solidFill>
                   <a:srgbClr val="EB0000"/>
                 </a:solidFill>
@@ -6721,14 +8162,58 @@
       </p:sp>
       <p:sp>
         <p:nvSpPr>
-          <p:cNvPr id="4" name="TextBox 3"/>
+          <p:cNvPr id="4" name="Rectangle 3"/>
+          <p:cNvSpPr/>
+          <p:nvPr/>
+        </p:nvSpPr>
+        <p:spPr>
+          <a:xfrm>
+            <a:off x="566928" y="1170432"/>
+            <a:ext cx="2011680" cy="31750"/>
+          </a:xfrm>
+          <a:prstGeom prst="rect">
+            <a:avLst/>
+          </a:prstGeom>
+          <a:solidFill>
+            <a:srgbClr val="EB0000"/>
+          </a:solidFill>
+          <a:ln>
+            <a:noFill/>
+          </a:ln>
+          <a:effectLst/>
+        </p:spPr>
+        <p:style>
+          <a:lnRef idx="1">
+            <a:schemeClr val="accent1"/>
+          </a:lnRef>
+          <a:fillRef idx="3">
+            <a:schemeClr val="accent1"/>
+          </a:fillRef>
+          <a:effectRef idx="2">
+            <a:schemeClr val="accent1"/>
+          </a:effectRef>
+          <a:fontRef idx="minor">
+            <a:schemeClr val="lt1"/>
+          </a:fontRef>
+        </p:style>
+        <p:txBody>
+          <a:bodyPr rtlCol="0" anchor="ctr"/>
+          <a:lstStyle/>
+          <a:p>
+            <a:pPr algn="ctr"/>
+          </a:p>
+        </p:txBody>
+      </p:sp>
+      <p:sp>
+        <p:nvSpPr>
+          <p:cNvPr id="5" name="TextBox 4"/>
           <p:cNvSpPr txBox="1"/>
           <p:nvPr/>
         </p:nvSpPr>
         <p:spPr>
           <a:xfrm>
-            <a:off x="640080" y="1280160"/>
-            <a:ext cx="10881360" cy="5212079"/>
+            <a:off x="640080" y="1417320"/>
+            <a:ext cx="10881360" cy="5074920"/>
           </a:xfrm>
           <a:prstGeom prst="rect">
             <a:avLst/>
@@ -6753,7 +8238,7 @@
                 </a:solidFill>
                 <a:latin typeface="Segoe UI"/>
               </a:rPr>
-              <a:t>•  2'739'734 Zug-Halte (SBB, Status REAL) über 48 Betriebstage (2026-03-31 – 2026-05-19)</a:t>
+              <a:t>•  2'739'734 gemessene Zug-Halte über 48 Betriebstage (2026-03-31 bis 2026-05-19)</a:t>
             </a:r>
           </a:p>
           <a:p>
@@ -6769,7 +8254,7 @@
                 </a:solidFill>
                 <a:latin typeface="Segoe UI"/>
               </a:rPr>
-              <a:t>•  3 offene Quellen: opentransportdata.swiss (Ist-Daten), data.sbb.ch</a:t>
+              <a:t>•  Drei offene Quellen: opentransportdata.swiss (Ist-Daten), data.sbb.ch</a:t>
             </a:r>
           </a:p>
           <a:p>
@@ -6801,7 +8286,7 @@
                 </a:solidFill>
                 <a:latin typeface="Segoe UI"/>
               </a:rPr>
-              <a:t>•  Design-Entscheidung: hohe Auflösung statt langer Zeitspanne —</a:t>
+              <a:t>•  Design-Entscheidung: hohe Auflösung statt langer Zeitspanne</a:t>
             </a:r>
           </a:p>
           <a:p>
@@ -6817,7 +8302,7 @@
                 </a:solidFill>
                 <a:latin typeface="Segoe UI"/>
               </a:rPr>
-              <a:t>•  48 Tage pro Zug-Halt (~85 Mio Datenpunkte) statt Jahres-Aggregate</a:t>
+              <a:t>–  48 Tage pro einzelnen Halt (~85 Mio Datenpunkte) statt Jahres-Summen</a:t>
             </a:r>
           </a:p>
           <a:p>
@@ -6833,7 +8318,7 @@
                 </a:solidFill>
                 <a:latin typeface="Segoe UI"/>
               </a:rPr>
-              <a:t>•  ermöglicht Stunden-, Bahnhof- und Wetter-Analysen</a:t>
+              <a:t>–  erst das ermöglicht Stunden-, Bahnhof- und Wetter-Vergleiche</a:t>
             </a:r>
           </a:p>
           <a:p>
@@ -6849,9 +8334,32 @@
                 </a:solidFill>
                 <a:latin typeface="Segoe UI"/>
               </a:rPr>
-              <a:t>•  Datenbereinigung: 70 physikalisch unmögliche Verspätungen (korrupte</a:t>
-            </a:r>
-          </a:p>
+              <a:t>•  Bereinigung: 70 unmögliche Werte (fehlerhafte Quell-Zeitstempel) entfernt</a:t>
+            </a:r>
+          </a:p>
+        </p:txBody>
+      </p:sp>
+      <p:sp>
+        <p:nvSpPr>
+          <p:cNvPr id="6" name="TextBox 5"/>
+          <p:cNvSpPr txBox="1"/>
+          <p:nvPr/>
+        </p:nvSpPr>
+        <p:spPr>
+          <a:xfrm>
+            <a:off x="457200" y="6446520"/>
+            <a:ext cx="8229600" cy="320040"/>
+          </a:xfrm>
+          <a:prstGeom prst="rect">
+            <a:avLst/>
+          </a:prstGeom>
+          <a:noFill/>
+        </p:spPr>
+        <p:txBody>
+          <a:bodyPr wrap="square">
+            <a:spAutoFit/>
+          </a:bodyPr>
+          <a:lstStyle/>
           <a:p>
             <a:pPr algn="l">
               <a:spcAft>
@@ -6859,13 +8367,52 @@
               </a:spcAft>
             </a:pPr>
             <a:r>
-              <a:rPr sz="1800" b="0">
-                <a:solidFill>
-                  <a:srgbClr val="1A1A1A"/>
-                </a:solidFill>
-                <a:latin typeface="Segoe UI"/>
-              </a:rPr>
-              <a:t>•  Quell-Zeitstempel) entfernt; Filter auf gemessene Ist-Ankünfte</a:t>
+              <a:rPr sz="900" b="0">
+                <a:solidFill>
+                  <a:srgbClr val="999999"/>
+                </a:solidFill>
+                <a:latin typeface="Segoe UI"/>
+              </a:rPr>
+              <a:t>SBB Tracker · ZHAW Scientific Programming FS2026</a:t>
+            </a:r>
+          </a:p>
+        </p:txBody>
+      </p:sp>
+      <p:sp>
+        <p:nvSpPr>
+          <p:cNvPr id="7" name="TextBox 6"/>
+          <p:cNvSpPr txBox="1"/>
+          <p:nvPr/>
+        </p:nvSpPr>
+        <p:spPr>
+          <a:xfrm>
+            <a:off x="10972800" y="6446520"/>
+            <a:ext cx="822960" cy="320040"/>
+          </a:xfrm>
+          <a:prstGeom prst="rect">
+            <a:avLst/>
+          </a:prstGeom>
+          <a:noFill/>
+        </p:spPr>
+        <p:txBody>
+          <a:bodyPr wrap="square">
+            <a:spAutoFit/>
+          </a:bodyPr>
+          <a:lstStyle/>
+          <a:p>
+            <a:pPr algn="r">
+              <a:spcAft>
+                <a:spcPts val="800"/>
+              </a:spcAft>
+            </a:pPr>
+            <a:r>
+              <a:rPr sz="900" b="0">
+                <a:solidFill>
+                  <a:srgbClr val="999999"/>
+                </a:solidFill>
+                <a:latin typeface="Segoe UI"/>
+              </a:rPr>
+              <a:t>4</a:t>
             </a:r>
           </a:p>
         </p:txBody>
@@ -6905,7 +8452,7 @@
         <p:spPr>
           <a:xfrm>
             <a:off x="0" y="0"/>
-            <a:ext cx="12191695" cy="164592"/>
+            <a:ext cx="12191695" cy="146304"/>
           </a:xfrm>
           <a:prstGeom prst="rect">
             <a:avLst/>
@@ -6948,8 +8495,8 @@
         </p:nvSpPr>
         <p:spPr>
           <a:xfrm>
-            <a:off x="548640" y="320040"/>
-            <a:ext cx="11064240" cy="822960"/>
+            <a:off x="548640" y="384048"/>
+            <a:ext cx="11064240" cy="777240"/>
           </a:xfrm>
           <a:prstGeom prst="rect">
             <a:avLst/>
@@ -6968,7 +8515,7 @@
               </a:spcAft>
             </a:pPr>
             <a:r>
-              <a:rPr sz="3000" b="1">
+              <a:rPr sz="2800" b="1">
                 <a:solidFill>
                   <a:srgbClr val="EB0000"/>
                 </a:solidFill>
@@ -6981,14 +8528,58 @@
       </p:sp>
       <p:sp>
         <p:nvSpPr>
-          <p:cNvPr id="4" name="TextBox 3"/>
+          <p:cNvPr id="4" name="Rectangle 3"/>
+          <p:cNvSpPr/>
+          <p:nvPr/>
+        </p:nvSpPr>
+        <p:spPr>
+          <a:xfrm>
+            <a:off x="566928" y="1170432"/>
+            <a:ext cx="2011680" cy="31750"/>
+          </a:xfrm>
+          <a:prstGeom prst="rect">
+            <a:avLst/>
+          </a:prstGeom>
+          <a:solidFill>
+            <a:srgbClr val="EB0000"/>
+          </a:solidFill>
+          <a:ln>
+            <a:noFill/>
+          </a:ln>
+          <a:effectLst/>
+        </p:spPr>
+        <p:style>
+          <a:lnRef idx="1">
+            <a:schemeClr val="accent1"/>
+          </a:lnRef>
+          <a:fillRef idx="3">
+            <a:schemeClr val="accent1"/>
+          </a:fillRef>
+          <a:effectRef idx="2">
+            <a:schemeClr val="accent1"/>
+          </a:effectRef>
+          <a:fontRef idx="minor">
+            <a:schemeClr val="lt1"/>
+          </a:fontRef>
+        </p:style>
+        <p:txBody>
+          <a:bodyPr rtlCol="0" anchor="ctr"/>
+          <a:lstStyle/>
+          <a:p>
+            <a:pPr algn="ctr"/>
+          </a:p>
+        </p:txBody>
+      </p:sp>
+      <p:sp>
+        <p:nvSpPr>
+          <p:cNvPr id="5" name="TextBox 4"/>
           <p:cNvSpPr txBox="1"/>
           <p:nvPr/>
         </p:nvSpPr>
         <p:spPr>
           <a:xfrm>
-            <a:off x="640080" y="1280160"/>
-            <a:ext cx="10881360" cy="5212079"/>
+            <a:off x="640080" y="1417320"/>
+            <a:ext cx="10881360" cy="5074920"/>
           </a:xfrm>
           <a:prstGeom prst="rect">
             <a:avLst/>
@@ -7013,7 +8604,7 @@
                 </a:solidFill>
                 <a:latin typeface="Segoe UI"/>
               </a:rPr>
-              <a:t>•  Pipeline: Download → SQLite-DB (3 Tabellen, SQL) → Aufbereitung →</a:t>
+              <a:t>•  Pipeline: Download → SQLite-Datenbank (3 Tabellen) → Aufbereitung →</a:t>
             </a:r>
           </a:p>
           <a:p>
@@ -7029,7 +8620,7 @@
                 </a:solidFill>
                 <a:latin typeface="Segoe UI"/>
               </a:rPr>
-              <a:t>•  Feature-Engineering (Zeit + Wetter via cos-korrigiertem KDTree)</a:t>
+              <a:t>•  Zeit- und Wetter-Merkmale pro Halt anreichern</a:t>
             </a:r>
           </a:p>
           <a:p>
@@ -7045,7 +8636,7 @@
                 </a:solidFill>
                 <a:latin typeface="Segoe UI"/>
               </a:rPr>
-              <a:t>•  4 statistische Tests, jeweils mit p-Wert UND Effektstärke:</a:t>
+              <a:t>•  Vier statistische Tests, jeweils mit p-Wert UND Effektstärke:</a:t>
             </a:r>
           </a:p>
           <a:p>
@@ -7061,55 +8652,7 @@
                 </a:solidFill>
                 <a:latin typeface="Segoe UI"/>
               </a:rPr>
-              <a:t>•  Welch's t-Test (+ Mann-Whitney, + Tagesmittel-Robustheit)</a:t>
-            </a:r>
-          </a:p>
-          <a:p>
-            <a:pPr algn="l" lvl="1">
-              <a:spcAft>
-                <a:spcPts val="800"/>
-              </a:spcAft>
-            </a:pPr>
-            <a:r>
-              <a:rPr sz="1500" b="0">
-                <a:solidFill>
-                  <a:srgbClr val="595959"/>
-                </a:solidFill>
-                <a:latin typeface="Segoe UI"/>
-              </a:rPr>
-              <a:t>•  Einweg-ANOVA + Tukey-HSD Post-hoc</a:t>
-            </a:r>
-          </a:p>
-          <a:p>
-            <a:pPr algn="l" lvl="1">
-              <a:spcAft>
-                <a:spcPts val="800"/>
-              </a:spcAft>
-            </a:pPr>
-            <a:r>
-              <a:rPr sz="1500" b="0">
-                <a:solidFill>
-                  <a:srgbClr val="595959"/>
-                </a:solidFill>
-                <a:latin typeface="Segoe UI"/>
-              </a:rPr>
-              <a:t>•  Pearson &amp; Spearman Korrelation (+ 95%-CI)</a:t>
-            </a:r>
-          </a:p>
-          <a:p>
-            <a:pPr algn="l" lvl="1">
-              <a:spcAft>
-                <a:spcPts val="800"/>
-              </a:spcAft>
-            </a:pPr>
-            <a:r>
-              <a:rPr sz="1500" b="0">
-                <a:solidFill>
-                  <a:srgbClr val="595959"/>
-                </a:solidFill>
-                <a:latin typeface="Segoe UI"/>
-              </a:rPr>
-              <a:t>•  Multiple OLS-Regression (+ Breusch-Pagan, VIF, Residuen)</a:t>
+              <a:t>–  Welch-t-Test, ANOVA, Korrelation, multiple Regression</a:t>
             </a:r>
           </a:p>
           <a:p>
@@ -7125,7 +8668,7 @@
                 </a:solidFill>
                 <a:latin typeface="Segoe UI"/>
               </a:rPr>
-              <a:t>•  LLM (Claude Sonnet 4.6) für qualitative Krisen-Tag-Hypothesen</a:t>
+              <a:t>•  Plus Robustheits- und Annahmen-Checks (ehrliche Statistik)</a:t>
             </a:r>
           </a:p>
           <a:p>
@@ -7141,7 +8684,101 @@
                 </a:solidFill>
                 <a:latin typeface="Segoe UI"/>
               </a:rPr>
-              <a:t>•  Tech: pandas · scipy · statsmodels · folium · streamlit · sqlite3</a:t>
+              <a:t>•  Ein Sprachmodell (Claude) für qualitative Ursachen-Hypothesen</a:t>
+            </a:r>
+          </a:p>
+          <a:p>
+            <a:pPr algn="l">
+              <a:spcAft>
+                <a:spcPts val="800"/>
+              </a:spcAft>
+            </a:pPr>
+            <a:r>
+              <a:rPr sz="1800" b="0">
+                <a:solidFill>
+                  <a:srgbClr val="1A1A1A"/>
+                </a:solidFill>
+                <a:latin typeface="Segoe UI"/>
+              </a:rPr>
+              <a:t>•  Werkzeuge: pandas · scipy · statsmodels · folium · streamlit · SQLite</a:t>
+            </a:r>
+          </a:p>
+        </p:txBody>
+      </p:sp>
+      <p:sp>
+        <p:nvSpPr>
+          <p:cNvPr id="6" name="TextBox 5"/>
+          <p:cNvSpPr txBox="1"/>
+          <p:nvPr/>
+        </p:nvSpPr>
+        <p:spPr>
+          <a:xfrm>
+            <a:off x="457200" y="6446520"/>
+            <a:ext cx="8229600" cy="320040"/>
+          </a:xfrm>
+          <a:prstGeom prst="rect">
+            <a:avLst/>
+          </a:prstGeom>
+          <a:noFill/>
+        </p:spPr>
+        <p:txBody>
+          <a:bodyPr wrap="square">
+            <a:spAutoFit/>
+          </a:bodyPr>
+          <a:lstStyle/>
+          <a:p>
+            <a:pPr algn="l">
+              <a:spcAft>
+                <a:spcPts val="800"/>
+              </a:spcAft>
+            </a:pPr>
+            <a:r>
+              <a:rPr sz="900" b="0">
+                <a:solidFill>
+                  <a:srgbClr val="999999"/>
+                </a:solidFill>
+                <a:latin typeface="Segoe UI"/>
+              </a:rPr>
+              <a:t>SBB Tracker · ZHAW Scientific Programming FS2026</a:t>
+            </a:r>
+          </a:p>
+        </p:txBody>
+      </p:sp>
+      <p:sp>
+        <p:nvSpPr>
+          <p:cNvPr id="7" name="TextBox 6"/>
+          <p:cNvSpPr txBox="1"/>
+          <p:nvPr/>
+        </p:nvSpPr>
+        <p:spPr>
+          <a:xfrm>
+            <a:off x="10972800" y="6446520"/>
+            <a:ext cx="822960" cy="320040"/>
+          </a:xfrm>
+          <a:prstGeom prst="rect">
+            <a:avLst/>
+          </a:prstGeom>
+          <a:noFill/>
+        </p:spPr>
+        <p:txBody>
+          <a:bodyPr wrap="square">
+            <a:spAutoFit/>
+          </a:bodyPr>
+          <a:lstStyle/>
+          <a:p>
+            <a:pPr algn="r">
+              <a:spcAft>
+                <a:spcPts val="800"/>
+              </a:spcAft>
+            </a:pPr>
+            <a:r>
+              <a:rPr sz="900" b="0">
+                <a:solidFill>
+                  <a:srgbClr val="999999"/>
+                </a:solidFill>
+                <a:latin typeface="Segoe UI"/>
+              </a:rPr>
+              <a:t>5</a:t>
             </a:r>
           </a:p>
         </p:txBody>
@@ -7181,7 +8818,7 @@
         <p:spPr>
           <a:xfrm>
             <a:off x="0" y="0"/>
-            <a:ext cx="12191695" cy="164592"/>
+            <a:ext cx="12191695" cy="146304"/>
           </a:xfrm>
           <a:prstGeom prst="rect">
             <a:avLst/>
@@ -7224,8 +8861,8 @@
         </p:nvSpPr>
         <p:spPr>
           <a:xfrm>
-            <a:off x="548640" y="320040"/>
-            <a:ext cx="11064240" cy="822960"/>
+            <a:off x="548640" y="384048"/>
+            <a:ext cx="11064240" cy="777240"/>
           </a:xfrm>
           <a:prstGeom prst="rect">
             <a:avLst/>
@@ -7244,7 +8881,7 @@
               </a:spcAft>
             </a:pPr>
             <a:r>
-              <a:rPr sz="3000" b="1">
+              <a:rPr sz="2800" b="1">
                 <a:solidFill>
                   <a:srgbClr val="EB0000"/>
                 </a:solidFill>
@@ -7257,14 +8894,58 @@
       </p:sp>
       <p:sp>
         <p:nvSpPr>
-          <p:cNvPr id="4" name="TextBox 3"/>
+          <p:cNvPr id="4" name="Rectangle 3"/>
+          <p:cNvSpPr/>
+          <p:nvPr/>
+        </p:nvSpPr>
+        <p:spPr>
+          <a:xfrm>
+            <a:off x="566928" y="1170432"/>
+            <a:ext cx="2011680" cy="31750"/>
+          </a:xfrm>
+          <a:prstGeom prst="rect">
+            <a:avLst/>
+          </a:prstGeom>
+          <a:solidFill>
+            <a:srgbClr val="EB0000"/>
+          </a:solidFill>
+          <a:ln>
+            <a:noFill/>
+          </a:ln>
+          <a:effectLst/>
+        </p:spPr>
+        <p:style>
+          <a:lnRef idx="1">
+            <a:schemeClr val="accent1"/>
+          </a:lnRef>
+          <a:fillRef idx="3">
+            <a:schemeClr val="accent1"/>
+          </a:fillRef>
+          <a:effectRef idx="2">
+            <a:schemeClr val="accent1"/>
+          </a:effectRef>
+          <a:fontRef idx="minor">
+            <a:schemeClr val="lt1"/>
+          </a:fontRef>
+        </p:style>
+        <p:txBody>
+          <a:bodyPr rtlCol="0" anchor="ctr"/>
+          <a:lstStyle/>
+          <a:p>
+            <a:pPr algn="ctr"/>
+          </a:p>
+        </p:txBody>
+      </p:sp>
+      <p:sp>
+        <p:nvSpPr>
+          <p:cNvPr id="5" name="TextBox 4"/>
           <p:cNvSpPr txBox="1"/>
           <p:nvPr/>
         </p:nvSpPr>
         <p:spPr>
           <a:xfrm>
-            <a:off x="640080" y="1280160"/>
-            <a:ext cx="10881360" cy="5212079"/>
+            <a:off x="640080" y="1417320"/>
+            <a:ext cx="10881360" cy="4069080"/>
           </a:xfrm>
           <a:prstGeom prst="rect">
             <a:avLst/>
@@ -7305,7 +8986,7 @@
                 </a:solidFill>
                 <a:latin typeface="Segoe UI"/>
               </a:rPr>
-              <a:t>•  Welch's t = 95.0, p &lt; 10⁻³⁰⁰ (hochsignifikant)</a:t>
+              <a:t>•  Welch-t = 95.0, p &lt; 10⁻³⁰⁰ (hochsignifikant)</a:t>
             </a:r>
           </a:p>
           <a:p>
@@ -7321,7 +9002,7 @@
                 </a:solidFill>
                 <a:latin typeface="Segoe UI"/>
               </a:rPr>
-              <a:t>•  Differenz 15.5 s, 95%-CI [15.2, 15.8] s</a:t>
+              <a:t>•  Differenz 15.5 s, 95%-Konfidenzintervall [15.2, 15.8] s</a:t>
             </a:r>
           </a:p>
           <a:p>
@@ -7337,7 +9018,7 @@
                 </a:solidFill>
                 <a:latin typeface="Segoe UI"/>
               </a:rPr>
-              <a:t>•  ABER Effektstärke Cohen's d = 0.12 → praktisch KLEIN</a:t>
+              <a:t>•  Effektstärke Cohen's d = 0.12 → praktisch klein</a:t>
             </a:r>
           </a:p>
           <a:p>
@@ -7353,9 +9034,87 @@
                 </a:solidFill>
                 <a:latin typeface="Segoe UI"/>
               </a:rPr>
-              <a:t>•  Robustheit: Effekt überlebt auf 48 Tagesmitteln (nicht bloss n-Artefakt)</a:t>
-            </a:r>
-          </a:p>
+              <a:t>•  Gegenchecks: Mann-Whitney-Test und Test auf 48 Tagesmitteln bestätigen es</a:t>
+            </a:r>
+          </a:p>
+        </p:txBody>
+      </p:sp>
+      <p:sp>
+        <p:nvSpPr>
+          <p:cNvPr id="6" name="Rounded Rectangle 5"/>
+          <p:cNvSpPr/>
+          <p:nvPr/>
+        </p:nvSpPr>
+        <p:spPr>
+          <a:xfrm>
+            <a:off x="640080" y="5532120"/>
+            <a:ext cx="10908792" cy="777240"/>
+          </a:xfrm>
+          <a:prstGeom prst="roundRect">
+            <a:avLst/>
+          </a:prstGeom>
+          <a:solidFill>
+            <a:srgbClr val="FCE9E9"/>
+          </a:solidFill>
+          <a:ln w="12700">
+            <a:solidFill>
+              <a:srgbClr val="EB0000"/>
+            </a:solidFill>
+          </a:ln>
+          <a:effectLst/>
+        </p:spPr>
+        <p:style>
+          <a:lnRef idx="1">
+            <a:schemeClr val="accent1"/>
+          </a:lnRef>
+          <a:fillRef idx="3">
+            <a:schemeClr val="accent1"/>
+          </a:fillRef>
+          <a:effectRef idx="2">
+            <a:schemeClr val="accent1"/>
+          </a:effectRef>
+          <a:fontRef idx="minor">
+            <a:schemeClr val="lt1"/>
+          </a:fontRef>
+        </p:style>
+        <p:txBody>
+          <a:bodyPr rtlCol="0" anchor="ctr" wrap="square" lIns="182880" rIns="182880" tIns="54864" bIns="54864"/>
+          <a:lstStyle/>
+          <a:p>
+            <a:pPr algn="ctr"/>
+            <a:r>
+              <a:rPr sz="1400" b="1">
+                <a:solidFill>
+                  <a:srgbClr val="1A1A1A"/>
+                </a:solidFill>
+                <a:latin typeface="Segoe UI"/>
+              </a:rPr>
+              <a:t>Signifikant ja — aber der Unterschied von ~15 s ist im Alltag kaum spürbar (d = 0.12).</a:t>
+            </a:r>
+          </a:p>
+        </p:txBody>
+      </p:sp>
+      <p:sp>
+        <p:nvSpPr>
+          <p:cNvPr id="7" name="TextBox 6"/>
+          <p:cNvSpPr txBox="1"/>
+          <p:nvPr/>
+        </p:nvSpPr>
+        <p:spPr>
+          <a:xfrm>
+            <a:off x="457200" y="6446520"/>
+            <a:ext cx="8229600" cy="320040"/>
+          </a:xfrm>
+          <a:prstGeom prst="rect">
+            <a:avLst/>
+          </a:prstGeom>
+          <a:noFill/>
+        </p:spPr>
+        <p:txBody>
+          <a:bodyPr wrap="square">
+            <a:spAutoFit/>
+          </a:bodyPr>
+          <a:lstStyle/>
           <a:p>
             <a:pPr algn="l">
               <a:spcAft>
@@ -7363,13 +9122,52 @@
               </a:spcAft>
             </a:pPr>
             <a:r>
-              <a:rPr sz="1800" b="0">
-                <a:solidFill>
-                  <a:srgbClr val="1A1A1A"/>
-                </a:solidFill>
-                <a:latin typeface="Segoe UI"/>
-              </a:rPr>
-              <a:t>•  Mann-Whitney-U bestätigt verteilungsfrei</a:t>
+              <a:rPr sz="900" b="0">
+                <a:solidFill>
+                  <a:srgbClr val="999999"/>
+                </a:solidFill>
+                <a:latin typeface="Segoe UI"/>
+              </a:rPr>
+              <a:t>SBB Tracker · ZHAW Scientific Programming FS2026</a:t>
+            </a:r>
+          </a:p>
+        </p:txBody>
+      </p:sp>
+      <p:sp>
+        <p:nvSpPr>
+          <p:cNvPr id="8" name="TextBox 7"/>
+          <p:cNvSpPr txBox="1"/>
+          <p:nvPr/>
+        </p:nvSpPr>
+        <p:spPr>
+          <a:xfrm>
+            <a:off x="10972800" y="6446520"/>
+            <a:ext cx="822960" cy="320040"/>
+          </a:xfrm>
+          <a:prstGeom prst="rect">
+            <a:avLst/>
+          </a:prstGeom>
+          <a:noFill/>
+        </p:spPr>
+        <p:txBody>
+          <a:bodyPr wrap="square">
+            <a:spAutoFit/>
+          </a:bodyPr>
+          <a:lstStyle/>
+          <a:p>
+            <a:pPr algn="r">
+              <a:spcAft>
+                <a:spcPts val="800"/>
+              </a:spcAft>
+            </a:pPr>
+            <a:r>
+              <a:rPr sz="900" b="0">
+                <a:solidFill>
+                  <a:srgbClr val="999999"/>
+                </a:solidFill>
+                <a:latin typeface="Segoe UI"/>
+              </a:rPr>
+              <a:t>6</a:t>
             </a:r>
           </a:p>
         </p:txBody>
@@ -7409,7 +9207,7 @@
         <p:spPr>
           <a:xfrm>
             <a:off x="0" y="0"/>
-            <a:ext cx="12191695" cy="164592"/>
+            <a:ext cx="12191695" cy="146304"/>
           </a:xfrm>
           <a:prstGeom prst="rect">
             <a:avLst/>
@@ -7452,8 +9250,8 @@
         </p:nvSpPr>
         <p:spPr>
           <a:xfrm>
-            <a:off x="548640" y="320040"/>
-            <a:ext cx="11064240" cy="822960"/>
+            <a:off x="548640" y="384048"/>
+            <a:ext cx="11064240" cy="777240"/>
           </a:xfrm>
           <a:prstGeom prst="rect">
             <a:avLst/>
@@ -7472,7 +9270,7 @@
               </a:spcAft>
             </a:pPr>
             <a:r>
-              <a:rPr sz="3000" b="1">
+              <a:rPr sz="2800" b="1">
                 <a:solidFill>
                   <a:srgbClr val="EB0000"/>
                 </a:solidFill>
@@ -7480,12 +9278,56 @@
               </a:rPr>
               <a:t>Ergebnis F2 — Linientyp (ANOVA)</a:t>
             </a:r>
+          </a:p>
+        </p:txBody>
+      </p:sp>
+      <p:sp>
+        <p:nvSpPr>
+          <p:cNvPr id="4" name="Rectangle 3"/>
+          <p:cNvSpPr/>
+          <p:nvPr/>
+        </p:nvSpPr>
+        <p:spPr>
+          <a:xfrm>
+            <a:off x="566928" y="1170432"/>
+            <a:ext cx="2011680" cy="31750"/>
+          </a:xfrm>
+          <a:prstGeom prst="rect">
+            <a:avLst/>
+          </a:prstGeom>
+          <a:solidFill>
+            <a:srgbClr val="EB0000"/>
+          </a:solidFill>
+          <a:ln>
+            <a:noFill/>
+          </a:ln>
+          <a:effectLst/>
+        </p:spPr>
+        <p:style>
+          <a:lnRef idx="1">
+            <a:schemeClr val="accent1"/>
+          </a:lnRef>
+          <a:fillRef idx="3">
+            <a:schemeClr val="accent1"/>
+          </a:fillRef>
+          <a:effectRef idx="2">
+            <a:schemeClr val="accent1"/>
+          </a:effectRef>
+          <a:fontRef idx="minor">
+            <a:schemeClr val="lt1"/>
+          </a:fontRef>
+        </p:style>
+        <p:txBody>
+          <a:bodyPr rtlCol="0" anchor="ctr"/>
+          <a:lstStyle/>
+          <a:p>
+            <a:pPr algn="ctr"/>
           </a:p>
         </p:txBody>
       </p:sp>
       <p:pic>
         <p:nvPicPr>
-          <p:cNvPr id="4" name="Picture 3" descr="03_analyse_visualisierung_cell21_plot0.png"/>
+          <p:cNvPr id="5" name="Picture 4" descr="03_analyse_visualisierung_cell21_plot0.png"/>
           <p:cNvPicPr>
             <a:picLocks noChangeAspect="1"/>
           </p:cNvPicPr>
@@ -7499,8 +9341,8 @@
         </p:blipFill>
         <p:spPr>
           <a:xfrm>
-            <a:off x="1229234" y="1325880"/>
-            <a:ext cx="9733226" cy="4754880"/>
+            <a:off x="1463206" y="1371600"/>
+            <a:ext cx="9265283" cy="4526280"/>
           </a:xfrm>
           <a:prstGeom prst="rect">
             <a:avLst/>
@@ -7509,14 +9351,14 @@
       </p:pic>
       <p:sp>
         <p:nvSpPr>
-          <p:cNvPr id="5" name="TextBox 4"/>
+          <p:cNvPr id="6" name="TextBox 5"/>
           <p:cNvSpPr txBox="1"/>
           <p:nvPr/>
         </p:nvSpPr>
         <p:spPr>
           <a:xfrm>
-            <a:off x="640080" y="6263640"/>
-            <a:ext cx="10881360" cy="457200"/>
+            <a:off x="640080" y="6126480"/>
+            <a:ext cx="10908792" cy="594360"/>
           </a:xfrm>
           <a:prstGeom prst="rect">
             <a:avLst/>
@@ -7541,7 +9383,85 @@
                 </a:solidFill>
                 <a:latin typeface="Segoe UI"/>
               </a:rPr>
-              <a:t>ANOVA F = 8'450.0, p &lt; 10⁻³⁰⁰, η² = 0.039 (klein) · Internationale Züge (TGV/EC/RJX) importieren Verspätung</a:t>
+              <a:t>ANOVA F = 8'450.0, p &lt; 10⁻³⁰⁰, η² = 0.039 (klein). Internationale Züge (TGV, EC, RJX) bringen Verspätung aus dem Ausland mit.</a:t>
+            </a:r>
+          </a:p>
+        </p:txBody>
+      </p:sp>
+      <p:sp>
+        <p:nvSpPr>
+          <p:cNvPr id="7" name="TextBox 6"/>
+          <p:cNvSpPr txBox="1"/>
+          <p:nvPr/>
+        </p:nvSpPr>
+        <p:spPr>
+          <a:xfrm>
+            <a:off x="457200" y="6446520"/>
+            <a:ext cx="8229600" cy="320040"/>
+          </a:xfrm>
+          <a:prstGeom prst="rect">
+            <a:avLst/>
+          </a:prstGeom>
+          <a:noFill/>
+        </p:spPr>
+        <p:txBody>
+          <a:bodyPr wrap="square">
+            <a:spAutoFit/>
+          </a:bodyPr>
+          <a:lstStyle/>
+          <a:p>
+            <a:pPr algn="l">
+              <a:spcAft>
+                <a:spcPts val="800"/>
+              </a:spcAft>
+            </a:pPr>
+            <a:r>
+              <a:rPr sz="900" b="0">
+                <a:solidFill>
+                  <a:srgbClr val="999999"/>
+                </a:solidFill>
+                <a:latin typeface="Segoe UI"/>
+              </a:rPr>
+              <a:t>SBB Tracker · ZHAW Scientific Programming FS2026</a:t>
+            </a:r>
+          </a:p>
+        </p:txBody>
+      </p:sp>
+      <p:sp>
+        <p:nvSpPr>
+          <p:cNvPr id="8" name="TextBox 7"/>
+          <p:cNvSpPr txBox="1"/>
+          <p:nvPr/>
+        </p:nvSpPr>
+        <p:spPr>
+          <a:xfrm>
+            <a:off x="10972800" y="6446520"/>
+            <a:ext cx="822960" cy="320040"/>
+          </a:xfrm>
+          <a:prstGeom prst="rect">
+            <a:avLst/>
+          </a:prstGeom>
+          <a:noFill/>
+        </p:spPr>
+        <p:txBody>
+          <a:bodyPr wrap="square">
+            <a:spAutoFit/>
+          </a:bodyPr>
+          <a:lstStyle/>
+          <a:p>
+            <a:pPr algn="r">
+              <a:spcAft>
+                <a:spcPts val="800"/>
+              </a:spcAft>
+            </a:pPr>
+            <a:r>
+              <a:rPr sz="900" b="0">
+                <a:solidFill>
+                  <a:srgbClr val="999999"/>
+                </a:solidFill>
+                <a:latin typeface="Segoe UI"/>
+              </a:rPr>
+              <a:t>7</a:t>
             </a:r>
           </a:p>
         </p:txBody>
@@ -7581,7 +9501,7 @@
         <p:spPr>
           <a:xfrm>
             <a:off x="0" y="0"/>
-            <a:ext cx="12191695" cy="164592"/>
+            <a:ext cx="12191695" cy="146304"/>
           </a:xfrm>
           <a:prstGeom prst="rect">
             <a:avLst/>
@@ -7624,8 +9544,8 @@
         </p:nvSpPr>
         <p:spPr>
           <a:xfrm>
-            <a:off x="548640" y="320040"/>
-            <a:ext cx="11064240" cy="822960"/>
+            <a:off x="548640" y="384048"/>
+            <a:ext cx="11064240" cy="777240"/>
           </a:xfrm>
           <a:prstGeom prst="rect">
             <a:avLst/>
@@ -7644,27 +9564,71 @@
               </a:spcAft>
             </a:pPr>
             <a:r>
-              <a:rPr sz="3000" b="1">
+              <a:rPr sz="2800" b="1">
                 <a:solidFill>
                   <a:srgbClr val="EB0000"/>
                 </a:solidFill>
                 <a:latin typeface="Segoe UI"/>
               </a:rPr>
-              <a:t>Ergebnis F3 — Wetter ↔ Verspätung</a:t>
-            </a:r>
-          </a:p>
-        </p:txBody>
-      </p:sp>
-      <p:sp>
-        <p:nvSpPr>
-          <p:cNvPr id="4" name="TextBox 3"/>
+              <a:t>Ergebnis F3 — Wetter und Verspätung</a:t>
+            </a:r>
+          </a:p>
+        </p:txBody>
+      </p:sp>
+      <p:sp>
+        <p:nvSpPr>
+          <p:cNvPr id="4" name="Rectangle 3"/>
+          <p:cNvSpPr/>
+          <p:nvPr/>
+        </p:nvSpPr>
+        <p:spPr>
+          <a:xfrm>
+            <a:off x="566928" y="1170432"/>
+            <a:ext cx="2011680" cy="31750"/>
+          </a:xfrm>
+          <a:prstGeom prst="rect">
+            <a:avLst/>
+          </a:prstGeom>
+          <a:solidFill>
+            <a:srgbClr val="EB0000"/>
+          </a:solidFill>
+          <a:ln>
+            <a:noFill/>
+          </a:ln>
+          <a:effectLst/>
+        </p:spPr>
+        <p:style>
+          <a:lnRef idx="1">
+            <a:schemeClr val="accent1"/>
+          </a:lnRef>
+          <a:fillRef idx="3">
+            <a:schemeClr val="accent1"/>
+          </a:fillRef>
+          <a:effectRef idx="2">
+            <a:schemeClr val="accent1"/>
+          </a:effectRef>
+          <a:fontRef idx="minor">
+            <a:schemeClr val="lt1"/>
+          </a:fontRef>
+        </p:style>
+        <p:txBody>
+          <a:bodyPr rtlCol="0" anchor="ctr"/>
+          <a:lstStyle/>
+          <a:p>
+            <a:pPr algn="ctr"/>
+          </a:p>
+        </p:txBody>
+      </p:sp>
+      <p:sp>
+        <p:nvSpPr>
+          <p:cNvPr id="5" name="TextBox 4"/>
           <p:cNvSpPr txBox="1"/>
           <p:nvPr/>
         </p:nvSpPr>
         <p:spPr>
           <a:xfrm>
-            <a:off x="640080" y="1280160"/>
-            <a:ext cx="10881360" cy="5212079"/>
+            <a:off x="640080" y="1417320"/>
+            <a:ext cx="10881360" cy="4069080"/>
           </a:xfrm>
           <a:prstGeom prst="rect">
             <a:avLst/>
@@ -7689,7 +9653,7 @@
                 </a:solidFill>
                 <a:latin typeface="Segoe UI"/>
               </a:rPr>
-              <a:t>•  Niederschlag: Pearson r = 0.0218 (p &lt; 10⁻²⁸⁶)</a:t>
+              <a:t>•  Niederschlag: Pearson r = 0.0218 (p &lt; 10⁻²⁸⁰)</a:t>
             </a:r>
           </a:p>
           <a:p>
@@ -7721,7 +9685,7 @@
                 </a:solidFill>
                 <a:latin typeface="Segoe UI"/>
               </a:rPr>
-              <a:t>•  Alle hochsignifikant — aber |r| &lt; 0.04: inhaltlich TRIVIAL</a:t>
+              <a:t>•  Alle hochsignifikant — aber |r| &lt; 0.04, also inhaltlich trivial</a:t>
             </a:r>
           </a:p>
           <a:p>
@@ -7737,7 +9701,7 @@
                 </a:solidFill>
                 <a:latin typeface="Segoe UI"/>
               </a:rPr>
-              <a:t>•  Spearman ≈ Pearson → Zusammenhänge schwach &amp; überwiegend monoton</a:t>
+              <a:t>•  Spearman ≈ Pearson → Zusammenhang schwach und überwiegend monoton</a:t>
             </a:r>
           </a:p>
           <a:p>
@@ -7753,9 +9717,87 @@
                 </a:solidFill>
                 <a:latin typeface="Segoe UI"/>
               </a:rPr>
-              <a:t>•  Wetter erklärt allein &lt; 0.3 % der Verspätungsvarianz</a:t>
-            </a:r>
-          </a:p>
+              <a:t>•  Wetter allein erklärt unter 0.3 % der Verspätungs-Schwankung</a:t>
+            </a:r>
+          </a:p>
+        </p:txBody>
+      </p:sp>
+      <p:sp>
+        <p:nvSpPr>
+          <p:cNvPr id="6" name="Rounded Rectangle 5"/>
+          <p:cNvSpPr/>
+          <p:nvPr/>
+        </p:nvSpPr>
+        <p:spPr>
+          <a:xfrm>
+            <a:off x="640080" y="5532120"/>
+            <a:ext cx="10908792" cy="777240"/>
+          </a:xfrm>
+          <a:prstGeom prst="roundRect">
+            <a:avLst/>
+          </a:prstGeom>
+          <a:solidFill>
+            <a:srgbClr val="FCE9E9"/>
+          </a:solidFill>
+          <a:ln w="12700">
+            <a:solidFill>
+              <a:srgbClr val="EB0000"/>
+            </a:solidFill>
+          </a:ln>
+          <a:effectLst/>
+        </p:spPr>
+        <p:style>
+          <a:lnRef idx="1">
+            <a:schemeClr val="accent1"/>
+          </a:lnRef>
+          <a:fillRef idx="3">
+            <a:schemeClr val="accent1"/>
+          </a:fillRef>
+          <a:effectRef idx="2">
+            <a:schemeClr val="accent1"/>
+          </a:effectRef>
+          <a:fontRef idx="minor">
+            <a:schemeClr val="lt1"/>
+          </a:fontRef>
+        </p:style>
+        <p:txBody>
+          <a:bodyPr rtlCol="0" anchor="ctr" wrap="square" lIns="182880" rIns="182880" tIns="54864" bIns="54864"/>
+          <a:lstStyle/>
+          <a:p>
+            <a:pPr algn="ctr"/>
+            <a:r>
+              <a:rPr sz="1400" b="1">
+                <a:solidFill>
+                  <a:srgbClr val="1A1A1A"/>
+                </a:solidFill>
+                <a:latin typeface="Segoe UI"/>
+              </a:rPr>
+              <a:t>Mehr Regen → minim mehr Verspätung, aber der Effekt ist praktisch vernachlässigbar.</a:t>
+            </a:r>
+          </a:p>
+        </p:txBody>
+      </p:sp>
+      <p:sp>
+        <p:nvSpPr>
+          <p:cNvPr id="7" name="TextBox 6"/>
+          <p:cNvSpPr txBox="1"/>
+          <p:nvPr/>
+        </p:nvSpPr>
+        <p:spPr>
+          <a:xfrm>
+            <a:off x="457200" y="6446520"/>
+            <a:ext cx="8229600" cy="320040"/>
+          </a:xfrm>
+          <a:prstGeom prst="rect">
+            <a:avLst/>
+          </a:prstGeom>
+          <a:noFill/>
+        </p:spPr>
+        <p:txBody>
+          <a:bodyPr wrap="square">
+            <a:spAutoFit/>
+          </a:bodyPr>
+          <a:lstStyle/>
           <a:p>
             <a:pPr algn="l">
               <a:spcAft>
@@ -7763,13 +9805,52 @@
               </a:spcAft>
             </a:pPr>
             <a:r>
-              <a:rPr sz="1800" b="0">
-                <a:solidFill>
-                  <a:srgbClr val="1A1A1A"/>
-                </a:solidFill>
-                <a:latin typeface="Segoe UI"/>
-              </a:rPr>
-              <a:t>•  Lehrstück: riesige Stichprobe macht winzige Effekte 'signifikant'</a:t>
+              <a:rPr sz="900" b="0">
+                <a:solidFill>
+                  <a:srgbClr val="999999"/>
+                </a:solidFill>
+                <a:latin typeface="Segoe UI"/>
+              </a:rPr>
+              <a:t>SBB Tracker · ZHAW Scientific Programming FS2026</a:t>
+            </a:r>
+          </a:p>
+        </p:txBody>
+      </p:sp>
+      <p:sp>
+        <p:nvSpPr>
+          <p:cNvPr id="8" name="TextBox 7"/>
+          <p:cNvSpPr txBox="1"/>
+          <p:nvPr/>
+        </p:nvSpPr>
+        <p:spPr>
+          <a:xfrm>
+            <a:off x="10972800" y="6446520"/>
+            <a:ext cx="822960" cy="320040"/>
+          </a:xfrm>
+          <a:prstGeom prst="rect">
+            <a:avLst/>
+          </a:prstGeom>
+          <a:noFill/>
+        </p:spPr>
+        <p:txBody>
+          <a:bodyPr wrap="square">
+            <a:spAutoFit/>
+          </a:bodyPr>
+          <a:lstStyle/>
+          <a:p>
+            <a:pPr algn="r">
+              <a:spcAft>
+                <a:spcPts val="800"/>
+              </a:spcAft>
+            </a:pPr>
+            <a:r>
+              <a:rPr sz="900" b="0">
+                <a:solidFill>
+                  <a:srgbClr val="999999"/>
+                </a:solidFill>
+                <a:latin typeface="Segoe UI"/>
+              </a:rPr>
+              <a:t>8</a:t>
             </a:r>
           </a:p>
         </p:txBody>
@@ -7809,7 +9890,7 @@
         <p:spPr>
           <a:xfrm>
             <a:off x="0" y="0"/>
-            <a:ext cx="12191695" cy="164592"/>
+            <a:ext cx="12191695" cy="146304"/>
           </a:xfrm>
           <a:prstGeom prst="rect">
             <a:avLst/>
@@ -7852,8 +9933,8 @@
         </p:nvSpPr>
         <p:spPr>
           <a:xfrm>
-            <a:off x="548640" y="320040"/>
-            <a:ext cx="11064240" cy="822960"/>
+            <a:off x="548640" y="384048"/>
+            <a:ext cx="11064240" cy="777240"/>
           </a:xfrm>
           <a:prstGeom prst="rect">
             <a:avLst/>
@@ -7872,20 +9953,64 @@
               </a:spcAft>
             </a:pPr>
             <a:r>
-              <a:rPr sz="3000" b="1">
+              <a:rPr sz="2800" b="1">
                 <a:solidFill>
                   <a:srgbClr val="EB0000"/>
                 </a:solidFill>
                 <a:latin typeface="Segoe UI"/>
               </a:rPr>
-              <a:t>Ergebnis F4 — Multiple OLS-Regression</a:t>
-            </a:r>
+              <a:t>Ergebnis F4 — Multiple Regression (OLS)</a:t>
+            </a:r>
+          </a:p>
+        </p:txBody>
+      </p:sp>
+      <p:sp>
+        <p:nvSpPr>
+          <p:cNvPr id="4" name="Rectangle 3"/>
+          <p:cNvSpPr/>
+          <p:nvPr/>
+        </p:nvSpPr>
+        <p:spPr>
+          <a:xfrm>
+            <a:off x="566928" y="1170432"/>
+            <a:ext cx="2011680" cy="31750"/>
+          </a:xfrm>
+          <a:prstGeom prst="rect">
+            <a:avLst/>
+          </a:prstGeom>
+          <a:solidFill>
+            <a:srgbClr val="EB0000"/>
+          </a:solidFill>
+          <a:ln>
+            <a:noFill/>
+          </a:ln>
+          <a:effectLst/>
+        </p:spPr>
+        <p:style>
+          <a:lnRef idx="1">
+            <a:schemeClr val="accent1"/>
+          </a:lnRef>
+          <a:fillRef idx="3">
+            <a:schemeClr val="accent1"/>
+          </a:fillRef>
+          <a:effectRef idx="2">
+            <a:schemeClr val="accent1"/>
+          </a:effectRef>
+          <a:fontRef idx="minor">
+            <a:schemeClr val="lt1"/>
+          </a:fontRef>
+        </p:style>
+        <p:txBody>
+          <a:bodyPr rtlCol="0" anchor="ctr"/>
+          <a:lstStyle/>
+          <a:p>
+            <a:pPr algn="ctr"/>
           </a:p>
         </p:txBody>
       </p:sp>
       <p:pic>
         <p:nvPicPr>
-          <p:cNvPr id="4" name="Picture 3" descr="03_analyse_visualisierung_cell30_plot0.png"/>
+          <p:cNvPr id="5" name="Picture 4" descr="03_analyse_visualisierung_cell30_plot0.png"/>
           <p:cNvPicPr>
             <a:picLocks noChangeAspect="1"/>
           </p:cNvPicPr>
@@ -7899,8 +10024,8 @@
         </p:blipFill>
         <p:spPr>
           <a:xfrm>
-            <a:off x="1849976" y="1325880"/>
-            <a:ext cx="8491743" cy="4754880"/>
+            <a:off x="2054104" y="1371600"/>
+            <a:ext cx="8083486" cy="4526280"/>
           </a:xfrm>
           <a:prstGeom prst="rect">
             <a:avLst/>
@@ -7909,14 +10034,14 @@
       </p:pic>
       <p:sp>
         <p:nvSpPr>
-          <p:cNvPr id="5" name="TextBox 4"/>
+          <p:cNvPr id="6" name="TextBox 5"/>
           <p:cNvSpPr txBox="1"/>
           <p:nvPr/>
         </p:nvSpPr>
         <p:spPr>
           <a:xfrm>
-            <a:off x="640080" y="6263640"/>
-            <a:ext cx="10881360" cy="457200"/>
+            <a:off x="640080" y="6126480"/>
+            <a:ext cx="10908792" cy="594360"/>
           </a:xfrm>
           <a:prstGeom prst="rect">
             <a:avLst/>
@@ -7941,7 +10066,85 @@
                 </a:solidFill>
                 <a:latin typeface="Segoe UI"/>
               </a:rPr>
-              <a:t>R² = 0.0430 (4.3 %) · Rush-Hour +10 s · Wochenende −12 s · Diagnostik: heteroskedastisch (Breusch-Pagan), VIF unauffällig</a:t>
+              <a:t>R² = 0.0430 (~4.3 %). Rush-Hour +10 s, Wochenende −12 s. Diagnostik offen ausgewiesen (Heteroskedastizität, VIF unauffällig).</a:t>
+            </a:r>
+          </a:p>
+        </p:txBody>
+      </p:sp>
+      <p:sp>
+        <p:nvSpPr>
+          <p:cNvPr id="7" name="TextBox 6"/>
+          <p:cNvSpPr txBox="1"/>
+          <p:nvPr/>
+        </p:nvSpPr>
+        <p:spPr>
+          <a:xfrm>
+            <a:off x="457200" y="6446520"/>
+            <a:ext cx="8229600" cy="320040"/>
+          </a:xfrm>
+          <a:prstGeom prst="rect">
+            <a:avLst/>
+          </a:prstGeom>
+          <a:noFill/>
+        </p:spPr>
+        <p:txBody>
+          <a:bodyPr wrap="square">
+            <a:spAutoFit/>
+          </a:bodyPr>
+          <a:lstStyle/>
+          <a:p>
+            <a:pPr algn="l">
+              <a:spcAft>
+                <a:spcPts val="800"/>
+              </a:spcAft>
+            </a:pPr>
+            <a:r>
+              <a:rPr sz="900" b="0">
+                <a:solidFill>
+                  <a:srgbClr val="999999"/>
+                </a:solidFill>
+                <a:latin typeface="Segoe UI"/>
+              </a:rPr>
+              <a:t>SBB Tracker · ZHAW Scientific Programming FS2026</a:t>
+            </a:r>
+          </a:p>
+        </p:txBody>
+      </p:sp>
+      <p:sp>
+        <p:nvSpPr>
+          <p:cNvPr id="8" name="TextBox 7"/>
+          <p:cNvSpPr txBox="1"/>
+          <p:nvPr/>
+        </p:nvSpPr>
+        <p:spPr>
+          <a:xfrm>
+            <a:off x="10972800" y="6446520"/>
+            <a:ext cx="822960" cy="320040"/>
+          </a:xfrm>
+          <a:prstGeom prst="rect">
+            <a:avLst/>
+          </a:prstGeom>
+          <a:noFill/>
+        </p:spPr>
+        <p:txBody>
+          <a:bodyPr wrap="square">
+            <a:spAutoFit/>
+          </a:bodyPr>
+          <a:lstStyle/>
+          <a:p>
+            <a:pPr algn="r">
+              <a:spcAft>
+                <a:spcPts val="800"/>
+              </a:spcAft>
+            </a:pPr>
+            <a:r>
+              <a:rPr sz="900" b="0">
+                <a:solidFill>
+                  <a:srgbClr val="999999"/>
+                </a:solidFill>
+                <a:latin typeface="Segoe UI"/>
+              </a:rPr>
+              <a:t>9</a:t>
             </a:r>
           </a:p>
         </p:txBody>

</xml_diff>